<commit_message>
Updated jCleanCim PPT to include .qea references
</commit_message>
<xml_diff>
--- a/doc/jCleanCimIntro.pptx
+++ b/doc/jCleanCimIntro.pptx
@@ -7057,15 +7057,99 @@
             <a:pPr marL="285750" lvl="1"/>
             <a:r>
               <a:rPr lang="en-GB" sz="2000" dirty="0"/>
-              <a:t>Creates in-memory representation of the whole content of UML from .</a:t>
+              <a:t>Creates in-memory representation of the whole content of UML from a </a:t>
             </a:r>
             <a:r>
               <a:rPr lang="en-GB" sz="2000" dirty="0" err="1"/>
+              <a:t>aspecifed</a:t>
+            </a:r>
+            <a:r>
+              <a:rPr lang="en-GB" sz="2000" dirty="0"/>
+              <a:t> </a:t>
+            </a:r>
+            <a:r>
+              <a:rPr lang="en-GB" sz="2000" dirty="0">
+                <a:solidFill>
+                  <a:schemeClr val="tx2"/>
+                </a:solidFill>
+              </a:rPr>
+              <a:t>.</a:t>
+            </a:r>
+            <a:r>
+              <a:rPr lang="en-GB" sz="2000" dirty="0" err="1">
+                <a:solidFill>
+                  <a:schemeClr val="tx2"/>
+                </a:solidFill>
+              </a:rPr>
               <a:t>eap</a:t>
             </a:r>
             <a:r>
+              <a:rPr lang="en-GB" sz="2000" dirty="0">
+                <a:solidFill>
+                  <a:schemeClr val="tx2"/>
+                </a:solidFill>
+              </a:rPr>
+              <a:t> </a:t>
+            </a:r>
+            <a:r>
               <a:rPr lang="en-GB" sz="2000" dirty="0"/>
-              <a:t> file</a:t>
+              <a:t>or </a:t>
+            </a:r>
+            <a:r>
+              <a:rPr lang="en-GB" sz="2000" dirty="0">
+                <a:solidFill>
+                  <a:schemeClr val="tx2"/>
+                </a:solidFill>
+              </a:rPr>
+              <a:t>.</a:t>
+            </a:r>
+            <a:r>
+              <a:rPr lang="en-GB" sz="2000" dirty="0" err="1">
+                <a:solidFill>
+                  <a:schemeClr val="tx2"/>
+                </a:solidFill>
+              </a:rPr>
+              <a:t>qea</a:t>
+            </a:r>
+            <a:r>
+              <a:rPr lang="en-GB" sz="2000" dirty="0">
+                <a:solidFill>
+                  <a:schemeClr val="tx2"/>
+                </a:solidFill>
+              </a:rPr>
+              <a:t> </a:t>
+            </a:r>
+            <a:r>
+              <a:rPr lang="en-GB" sz="2000" dirty="0"/>
+              <a:t>project file (support for 64-bit </a:t>
+            </a:r>
+            <a:r>
+              <a:rPr lang="en-GB" sz="2000" dirty="0">
+                <a:solidFill>
+                  <a:schemeClr val="tx2"/>
+                </a:solidFill>
+              </a:rPr>
+              <a:t>.</a:t>
+            </a:r>
+            <a:r>
+              <a:rPr lang="en-GB" sz="2000" dirty="0" err="1">
+                <a:solidFill>
+                  <a:schemeClr val="tx2"/>
+                </a:solidFill>
+              </a:rPr>
+              <a:t>qea</a:t>
+            </a:r>
+            <a:r>
+              <a:rPr lang="en-GB" sz="2000" dirty="0">
+                <a:solidFill>
+                  <a:schemeClr val="tx2"/>
+                </a:solidFill>
+              </a:rPr>
+              <a:t> </a:t>
+            </a:r>
+            <a:r>
+              <a:rPr lang="en-GB" sz="2000" dirty="0"/>
+              <a:t>introduced in 2.4.0)</a:t>
             </a:r>
           </a:p>
           <a:p>
@@ -12934,14 +13018,6 @@
             <a:r>
               <a:rPr lang="en-GB" sz="3200" dirty="0" err="1"/>
               <a:t>eap</a:t>
-            </a:r>
-            <a:r>
-              <a:rPr lang="en-GB" sz="3200" dirty="0"/>
-              <a:t>/.</a:t>
-            </a:r>
-            <a:r>
-              <a:rPr lang="en-GB" sz="3200" dirty="0" err="1"/>
-              <a:t>eapx</a:t>
             </a:r>
             <a:r>
               <a:rPr lang="en-GB" sz="3200" dirty="0"/>
@@ -14576,14 +14652,6 @@
             </a:r>
             <a:r>
               <a:rPr lang="en-GB" sz="3200" dirty="0"/>
-              <a:t>/.</a:t>
-            </a:r>
-            <a:r>
-              <a:rPr lang="en-GB" sz="3200" dirty="0" err="1"/>
-              <a:t>qeax</a:t>
-            </a:r>
-            <a:r>
-              <a:rPr lang="en-GB" sz="3200" dirty="0"/>
               <a:t> repository:</a:t>
             </a:r>
             <a:br>
@@ -16502,7 +16570,7 @@
                   <a:schemeClr val="tx2"/>
                 </a:solidFill>
               </a:rPr>
-              <a:t>eapx</a:t>
+              <a:t>feap</a:t>
             </a:r>
             <a:r>
               <a:rPr lang="en-US" sz="2000" dirty="0">
@@ -16510,7 +16578,7 @@
                   <a:schemeClr val="tx2"/>
                 </a:solidFill>
               </a:rPr>
-              <a:t>, .</a:t>
+              <a:t>, and .</a:t>
             </a:r>
             <a:r>
               <a:rPr lang="en-US" sz="2000" dirty="0" err="1">
@@ -16518,39 +16586,7 @@
                   <a:schemeClr val="tx2"/>
                 </a:solidFill>
               </a:rPr>
-              <a:t>feap</a:t>
-            </a:r>
-            <a:r>
-              <a:rPr lang="en-US" sz="2000" dirty="0">
-                <a:solidFill>
-                  <a:schemeClr val="tx2"/>
-                </a:solidFill>
-              </a:rPr>
-              <a:t>, .</a:t>
-            </a:r>
-            <a:r>
-              <a:rPr lang="en-US" sz="2000" dirty="0" err="1">
-                <a:solidFill>
-                  <a:schemeClr val="tx2"/>
-                </a:solidFill>
-              </a:rPr>
               <a:t>qea</a:t>
-            </a:r>
-            <a:r>
-              <a:rPr lang="en-US" sz="2000" dirty="0">
-                <a:solidFill>
-                  <a:schemeClr val="tx2"/>
-                </a:solidFill>
-              </a:rPr>
-              <a:t> and .</a:t>
-            </a:r>
-            <a:r>
-              <a:rPr lang="en-US" sz="2000" dirty="0" err="1">
-                <a:solidFill>
-                  <a:schemeClr val="tx2"/>
-                </a:solidFill>
-              </a:rPr>
-              <a:t>qeax</a:t>
             </a:r>
             <a:r>
               <a:rPr lang="en-US" sz="2000" dirty="0">
@@ -16976,6 +17012,22 @@
                 </a:solidFill>
               </a:rPr>
               <a:t>eap</a:t>
+            </a:r>
+            <a:r>
+              <a:rPr lang="en-US" sz="2000" dirty="0">
+                <a:solidFill>
+                  <a:schemeClr val="tx2"/>
+                </a:solidFill>
+              </a:rPr>
+              <a:t> or .</a:t>
+            </a:r>
+            <a:r>
+              <a:rPr lang="en-US" sz="2000" dirty="0" err="1">
+                <a:solidFill>
+                  <a:schemeClr val="tx2"/>
+                </a:solidFill>
+              </a:rPr>
+              <a:t>qea</a:t>
             </a:r>
             <a:r>
               <a:rPr lang="en-US" sz="2000" dirty="0">
@@ -46729,7 +46781,7 @@
             <a:pPr eaLnBrk="1" hangingPunct="1"/>
             <a:r>
               <a:rPr lang="en-GB" sz="3200" dirty="0"/>
-              <a:t>Note for the 32-bit distributions</a:t>
+              <a:t>Note for the 64-bit distributions</a:t>
             </a:r>
           </a:p>
         </p:txBody>

</xml_diff>

<commit_message>
ppt and config updates
</commit_message>
<xml_diff>
--- a/doc/jCleanCimIntro.pptx
+++ b/doc/jCleanCimIntro.pptx
@@ -4674,8 +4674,8 @@
         </p:nvSpPr>
         <p:spPr>
           <a:xfrm>
-            <a:off x="251520" y="1950435"/>
-            <a:ext cx="816781" cy="538460"/>
+            <a:off x="114076" y="1950435"/>
+            <a:ext cx="1156963" cy="538460"/>
           </a:xfrm>
           <a:prstGeom prst="foldedCorner">
             <a:avLst/>
@@ -4764,6 +4764,38 @@
                 <a:ea typeface="+mn-ea"/>
                 <a:cs typeface="+mn-cs"/>
               </a:rPr>
+              <a:t>/.</a:t>
+            </a:r>
+            <a:r>
+              <a:rPr kumimoji="0" lang="en-GB" sz="1600" b="1" i="0" u="none" strike="noStrike" kern="0" cap="none" spc="0" normalizeH="0" baseline="0" noProof="0" dirty="0" err="1">
+                <a:ln>
+                  <a:noFill/>
+                </a:ln>
+                <a:solidFill>
+                  <a:srgbClr val="1F497D"/>
+                </a:solidFill>
+                <a:effectLst/>
+                <a:uLnTx/>
+                <a:uFillTx/>
+                <a:ea typeface="+mn-ea"/>
+                <a:cs typeface="+mn-cs"/>
+              </a:rPr>
+              <a:t>qea</a:t>
+            </a:r>
+            <a:r>
+              <a:rPr kumimoji="0" lang="en-GB" sz="1600" b="1" i="0" u="none" strike="noStrike" kern="0" cap="none" spc="0" normalizeH="0" baseline="0" noProof="0" dirty="0">
+                <a:ln>
+                  <a:noFill/>
+                </a:ln>
+                <a:solidFill>
+                  <a:srgbClr val="1F497D"/>
+                </a:solidFill>
+                <a:effectLst/>
+                <a:uLnTx/>
+                <a:uFillTx/>
+                <a:ea typeface="+mn-ea"/>
+                <a:cs typeface="+mn-cs"/>
+              </a:rPr>
               <a:t> (UML)</a:t>
             </a:r>
           </a:p>
@@ -4773,6 +4805,7 @@
         <p:nvCxnSpPr>
           <p:cNvPr id="54" name="Straight Arrow Connector 53"/>
           <p:cNvCxnSpPr>
+            <a:cxnSpLocks/>
             <a:stCxn id="53" idx="2"/>
             <a:endCxn id="47" idx="1"/>
           </p:cNvCxnSpPr>
@@ -4780,8 +4813,8 @@
         </p:nvCxnSpPr>
         <p:spPr>
           <a:xfrm rot="16200000" flipH="1">
-            <a:off x="1025436" y="2123369"/>
-            <a:ext cx="293711" cy="1024761"/>
+            <a:off x="1041760" y="2139693"/>
+            <a:ext cx="293711" cy="992114"/>
           </a:xfrm>
           <a:prstGeom prst="bentConnector2">
             <a:avLst/>
@@ -7419,15 +7452,63 @@
             </a:r>
             <a:r>
               <a:rPr lang="en-GB" sz="2000" dirty="0"/>
-              <a:t> of a UML model provided in an .</a:t>
-            </a:r>
-            <a:r>
-              <a:rPr lang="en-GB" sz="2000" dirty="0" err="1"/>
+              <a:t> of a UML model provided in an </a:t>
+            </a:r>
+            <a:r>
+              <a:rPr lang="en-GB" sz="2000" dirty="0">
+                <a:solidFill>
+                  <a:schemeClr val="tx2"/>
+                </a:solidFill>
+              </a:rPr>
+              <a:t>.</a:t>
+            </a:r>
+            <a:r>
+              <a:rPr lang="en-GB" sz="2000" dirty="0" err="1">
+                <a:solidFill>
+                  <a:schemeClr val="tx2"/>
+                </a:solidFill>
+              </a:rPr>
               <a:t>eap</a:t>
             </a:r>
             <a:r>
+              <a:rPr lang="en-GB" sz="2000" dirty="0">
+                <a:solidFill>
+                  <a:schemeClr val="tx2"/>
+                </a:solidFill>
+              </a:rPr>
+              <a:t> </a:t>
+            </a:r>
+            <a:r>
               <a:rPr lang="en-GB" sz="2000" dirty="0"/>
-              <a:t> file: UML of standard IEC CIM (base and extensions), UML of IEC61850 family, and custom extensions of any of these</a:t>
+              <a:t>or </a:t>
+            </a:r>
+            <a:r>
+              <a:rPr lang="en-GB" sz="2000" dirty="0">
+                <a:solidFill>
+                  <a:schemeClr val="tx2"/>
+                </a:solidFill>
+              </a:rPr>
+              <a:t>.</a:t>
+            </a:r>
+            <a:r>
+              <a:rPr lang="en-GB" sz="2000" dirty="0" err="1">
+                <a:solidFill>
+                  <a:schemeClr val="tx2"/>
+                </a:solidFill>
+              </a:rPr>
+              <a:t>qea</a:t>
+            </a:r>
+            <a:r>
+              <a:rPr lang="en-GB" sz="2000" dirty="0">
+                <a:solidFill>
+                  <a:schemeClr val="tx2"/>
+                </a:solidFill>
+              </a:rPr>
+              <a:t> </a:t>
+            </a:r>
+            <a:r>
+              <a:rPr lang="en-GB" sz="2000" dirty="0"/>
+              <a:t>file: UML of standard IEC CIM (base and extensions), UML of IEC61850 family, and custom extensions of any of these</a:t>
             </a:r>
           </a:p>
           <a:p>
@@ -7870,7 +7951,7 @@
         <p:spPr bwMode="auto">
           <a:xfrm>
             <a:off x="4317966" y="2169150"/>
-            <a:ext cx="3253444" cy="738664"/>
+            <a:ext cx="3253444" cy="749757"/>
           </a:xfrm>
           <a:prstGeom prst="rect">
             <a:avLst/>
@@ -7900,26 +7981,11 @@
               </a:spcBef>
             </a:pPr>
             <a:r>
-              <a:rPr lang="it-IT" sz="1200" dirty="0" err="1">
-                <a:latin typeface="+mj-lt"/>
-              </a:rPr>
-              <a:t>model.filename</a:t>
-            </a:r>
-            <a:r>
               <a:rPr lang="it-IT" sz="1200" dirty="0">
                 <a:latin typeface="+mj-lt"/>
               </a:rPr>
-              <a:t>   = base-</a:t>
-            </a:r>
-            <a:r>
-              <a:rPr lang="it-IT" sz="1200" dirty="0" err="1">
-                <a:latin typeface="+mj-lt"/>
-              </a:rPr>
-              <a:t>small.eap</a:t>
-            </a:r>
-            <a:endParaRPr lang="it-IT" sz="1200" dirty="0">
-              <a:latin typeface="+mj-lt"/>
-            </a:endParaRPr>
+              <a:t>model.filename   = base-small.qea</a:t>
+            </a:r>
           </a:p>
           <a:p>
             <a:pPr>
@@ -8009,7 +8075,7 @@
         <p:spPr bwMode="auto">
           <a:xfrm>
             <a:off x="4309845" y="3356705"/>
-            <a:ext cx="3253444" cy="738664"/>
+            <a:ext cx="3253444" cy="749757"/>
           </a:xfrm>
           <a:prstGeom prst="rect">
             <a:avLst/>
@@ -8039,26 +8105,11 @@
               </a:spcBef>
             </a:pPr>
             <a:r>
-              <a:rPr lang="it-IT" sz="1200" dirty="0" err="1">
-                <a:latin typeface="+mj-lt"/>
-              </a:rPr>
-              <a:t>model.filename</a:t>
-            </a:r>
-            <a:r>
               <a:rPr lang="it-IT" sz="1200" dirty="0">
                 <a:latin typeface="+mj-lt"/>
               </a:rPr>
-              <a:t>    = base-</a:t>
-            </a:r>
-            <a:r>
-              <a:rPr lang="it-IT" sz="1200" dirty="0" err="1">
-                <a:latin typeface="+mj-lt"/>
-              </a:rPr>
-              <a:t>small.eap</a:t>
-            </a:r>
-            <a:endParaRPr lang="it-IT" sz="1200" dirty="0">
-              <a:latin typeface="+mj-lt"/>
-            </a:endParaRPr>
+              <a:t>model.filename    = base-small.qea</a:t>
+            </a:r>
           </a:p>
           <a:p>
             <a:pPr>
@@ -8449,8 +8500,17 @@
               <a:rPr lang="en-GB" sz="1200" dirty="0">
                 <a:latin typeface="+mj-lt"/>
               </a:rPr>
-              <a:t>         = base-small.eap</a:t>
-            </a:r>
+              <a:t>         = base-</a:t>
+            </a:r>
+            <a:r>
+              <a:rPr lang="en-GB" sz="1200" dirty="0" err="1">
+                <a:latin typeface="+mj-lt"/>
+              </a:rPr>
+              <a:t>small.qea</a:t>
+            </a:r>
+            <a:endParaRPr lang="en-GB" sz="1200" dirty="0">
+              <a:latin typeface="+mj-lt"/>
+            </a:endParaRPr>
           </a:p>
           <a:p>
             <a:pPr>
@@ -8636,8 +8696,17 @@
                 <a:rPr lang="en-GB" sz="1200" dirty="0">
                   <a:latin typeface="+mj-lt"/>
                 </a:rPr>
-                <a:t>                      	= base-small.eap</a:t>
+                <a:t>                      	= base-</a:t>
               </a:r>
+              <a:r>
+                <a:rPr lang="en-GB" sz="1200" dirty="0" err="1">
+                  <a:latin typeface="+mj-lt"/>
+                </a:rPr>
+                <a:t>small.qea</a:t>
+              </a:r>
+              <a:endParaRPr lang="en-GB" sz="1200" dirty="0">
+                <a:latin typeface="+mj-lt"/>
+              </a:endParaRPr>
             </a:p>
             <a:p>
               <a:pPr>
@@ -9050,23 +9119,63 @@
             </a:pPr>
             <a:r>
               <a:rPr lang="en-GB" sz="1600" dirty="0"/>
-              <a:t>For any function, you need at least an .</a:t>
-            </a:r>
-            <a:r>
-              <a:rPr lang="en-GB" sz="1600" dirty="0" err="1"/>
+              <a:t>For any function, you need at least an </a:t>
+            </a:r>
+            <a:r>
+              <a:rPr lang="en-GB" sz="1600" dirty="0">
+                <a:solidFill>
+                  <a:schemeClr val="tx2"/>
+                </a:solidFill>
+              </a:rPr>
+              <a:t>.</a:t>
+            </a:r>
+            <a:r>
+              <a:rPr lang="en-GB" sz="1600" dirty="0" err="1">
+                <a:solidFill>
+                  <a:schemeClr val="tx2"/>
+                </a:solidFill>
+              </a:rPr>
               <a:t>eap</a:t>
             </a:r>
             <a:r>
+              <a:rPr lang="en-GB" sz="1600" dirty="0">
+                <a:solidFill>
+                  <a:schemeClr val="tx2"/>
+                </a:solidFill>
+              </a:rPr>
+              <a:t> </a:t>
+            </a:r>
+            <a:r>
               <a:rPr lang="en-GB" sz="1600" dirty="0"/>
-              <a:t> or .</a:t>
-            </a:r>
-            <a:r>
-              <a:rPr lang="en-GB" sz="1600" dirty="0" err="1"/>
+              <a:t>or </a:t>
+            </a:r>
+            <a:r>
+              <a:rPr lang="en-GB" sz="1600" dirty="0">
+                <a:solidFill>
+                  <a:schemeClr val="tx2"/>
+                </a:solidFill>
+              </a:rPr>
+              <a:t>.</a:t>
+            </a:r>
+            <a:r>
+              <a:rPr lang="en-GB" sz="1600" dirty="0" err="1">
+                <a:solidFill>
+                  <a:schemeClr val="tx2"/>
+                </a:solidFill>
+              </a:rPr>
               <a:t>qea</a:t>
             </a:r>
             <a:r>
+              <a:rPr lang="en-GB" sz="1600" dirty="0">
+                <a:solidFill>
+                  <a:schemeClr val="tx2"/>
+                </a:solidFill>
+              </a:rPr>
+              <a:t> </a:t>
+            </a:r>
+            <a:r>
               <a:rPr lang="en-GB" sz="1600" dirty="0"/>
-              <a:t> model file (i.e. 32-bit &amp; 64-bit distros)</a:t>
+              <a:t>model file (i.e. for 32-bit or 64-bit distros)</a:t>
             </a:r>
           </a:p>
           <a:p>
@@ -9133,6 +9242,22 @@
                 </a:solidFill>
               </a:rPr>
               <a:t>small.eap</a:t>
+            </a:r>
+            <a:r>
+              <a:rPr lang="en-GB" sz="1400" b="1" dirty="0">
+                <a:solidFill>
+                  <a:schemeClr val="tx2"/>
+                </a:solidFill>
+              </a:rPr>
+              <a:t>/base-</a:t>
+            </a:r>
+            <a:r>
+              <a:rPr lang="en-GB" sz="1400" b="1" dirty="0" err="1">
+                <a:solidFill>
+                  <a:schemeClr val="tx2"/>
+                </a:solidFill>
+              </a:rPr>
+              <a:t>small.qea</a:t>
             </a:r>
             <a:r>
               <a:rPr lang="en-GB" sz="1400" b="1" dirty="0">
@@ -9545,15 +9670,63 @@
             <a:pPr marL="285750" lvl="1" eaLnBrk="1" hangingPunct="1"/>
             <a:r>
               <a:rPr lang="en-GB" sz="1600" dirty="0"/>
-              <a:t>Currently, jCleanCim ignores everything but the first root in the .</a:t>
-            </a:r>
-            <a:r>
-              <a:rPr lang="en-GB" sz="1600" dirty="0" err="1"/>
+              <a:t>Currently, jCleanCim ignores everything but the first root in the </a:t>
+            </a:r>
+            <a:r>
+              <a:rPr lang="en-GB" sz="1600" dirty="0">
+                <a:solidFill>
+                  <a:schemeClr val="tx2"/>
+                </a:solidFill>
+              </a:rPr>
+              <a:t>.</a:t>
+            </a:r>
+            <a:r>
+              <a:rPr lang="en-GB" sz="1600" dirty="0" err="1">
+                <a:solidFill>
+                  <a:schemeClr val="tx2"/>
+                </a:solidFill>
+              </a:rPr>
               <a:t>eap</a:t>
             </a:r>
             <a:r>
+              <a:rPr lang="en-GB" sz="1600" dirty="0">
+                <a:solidFill>
+                  <a:schemeClr val="tx2"/>
+                </a:solidFill>
+              </a:rPr>
+              <a:t> </a:t>
+            </a:r>
+            <a:r>
               <a:rPr lang="en-GB" sz="1600" dirty="0"/>
-              <a:t> project</a:t>
+              <a:t>or </a:t>
+            </a:r>
+            <a:r>
+              <a:rPr lang="en-GB" sz="1600" dirty="0">
+                <a:solidFill>
+                  <a:schemeClr val="tx2"/>
+                </a:solidFill>
+              </a:rPr>
+              <a:t>.</a:t>
+            </a:r>
+            <a:r>
+              <a:rPr lang="en-GB" sz="1600" dirty="0" err="1">
+                <a:solidFill>
+                  <a:schemeClr val="tx2"/>
+                </a:solidFill>
+              </a:rPr>
+              <a:t>qea</a:t>
+            </a:r>
+            <a:r>
+              <a:rPr lang="en-GB" sz="1600" dirty="0">
+                <a:solidFill>
+                  <a:schemeClr val="tx2"/>
+                </a:solidFill>
+              </a:rPr>
+              <a:t> </a:t>
+            </a:r>
+            <a:r>
+              <a:rPr lang="en-GB" sz="1600" dirty="0"/>
+              <a:t>project</a:t>
             </a:r>
           </a:p>
           <a:p>
@@ -10217,7 +10390,7 @@
         <p:spPr bwMode="auto">
           <a:xfrm>
             <a:off x="792653" y="4981784"/>
-            <a:ext cx="2111375" cy="954107"/>
+            <a:ext cx="2111375" cy="1169551"/>
           </a:xfrm>
           <a:prstGeom prst="rect">
             <a:avLst/>
@@ -10255,6 +10428,22 @@
                 </a:solidFill>
               </a:rPr>
               <a:t>small.eap</a:t>
+            </a:r>
+            <a:r>
+              <a:rPr lang="en-GB" sz="1400" dirty="0">
+                <a:solidFill>
+                  <a:schemeClr val="tx2"/>
+                </a:solidFill>
+              </a:rPr>
+              <a:t>/base-</a:t>
+            </a:r>
+            <a:r>
+              <a:rPr lang="en-GB" sz="1400" dirty="0" err="1">
+                <a:solidFill>
+                  <a:schemeClr val="tx2"/>
+                </a:solidFill>
+              </a:rPr>
+              <a:t>small.qea</a:t>
             </a:r>
             <a:r>
               <a:rPr lang="en-GB" sz="1400" dirty="0"/>
@@ -10887,7 +11076,7 @@
         <p:spPr bwMode="auto">
           <a:xfrm>
             <a:off x="792653" y="4981784"/>
-            <a:ext cx="2111375" cy="954107"/>
+            <a:ext cx="2111375" cy="1169551"/>
           </a:xfrm>
           <a:prstGeom prst="rect">
             <a:avLst/>
@@ -10925,6 +11114,22 @@
                 </a:solidFill>
               </a:rPr>
               <a:t>small.eap</a:t>
+            </a:r>
+            <a:r>
+              <a:rPr lang="en-GB" sz="1400" dirty="0">
+                <a:solidFill>
+                  <a:schemeClr val="tx2"/>
+                </a:solidFill>
+              </a:rPr>
+              <a:t>/base-</a:t>
+            </a:r>
+            <a:r>
+              <a:rPr lang="en-GB" sz="1400" dirty="0" err="1">
+                <a:solidFill>
+                  <a:schemeClr val="tx2"/>
+                </a:solidFill>
+              </a:rPr>
+              <a:t>small.qea</a:t>
             </a:r>
             <a:r>
               <a:rPr lang="en-GB" sz="1400" dirty="0"/>
@@ -11461,7 +11666,7 @@
         <p:spPr bwMode="auto">
           <a:xfrm>
             <a:off x="792653" y="4981784"/>
-            <a:ext cx="2111375" cy="954107"/>
+            <a:ext cx="2111375" cy="1169551"/>
           </a:xfrm>
           <a:prstGeom prst="rect">
             <a:avLst/>
@@ -11499,6 +11704,22 @@
                 </a:solidFill>
               </a:rPr>
               <a:t>small.eap</a:t>
+            </a:r>
+            <a:r>
+              <a:rPr lang="en-GB" sz="1400" dirty="0">
+                <a:solidFill>
+                  <a:schemeClr val="tx2"/>
+                </a:solidFill>
+              </a:rPr>
+              <a:t>/base-</a:t>
+            </a:r>
+            <a:r>
+              <a:rPr lang="en-GB" sz="1400" dirty="0" err="1">
+                <a:solidFill>
+                  <a:schemeClr val="tx2"/>
+                </a:solidFill>
+              </a:rPr>
+              <a:t>small.qea</a:t>
             </a:r>
             <a:r>
               <a:rPr lang="en-GB" sz="1400" dirty="0"/>
@@ -12066,6 +12287,14 @@
             </a:r>
             <a:r>
               <a:rPr lang="en-GB" sz="3200" dirty="0"/>
+              <a:t> or .</a:t>
+            </a:r>
+            <a:r>
+              <a:rPr lang="en-GB" sz="3200" dirty="0" err="1"/>
+              <a:t>qea</a:t>
+            </a:r>
+            <a:r>
+              <a:rPr lang="en-GB" sz="3200" dirty="0"/>
               <a:t> repository:</a:t>
             </a:r>
             <a:br>
@@ -12272,7 +12501,7 @@
               </a:spcBef>
             </a:pPr>
             <a:r>
-              <a:rPr lang="it-IT" sz="1200" b="1" dirty="0" err="1">
+              <a:rPr lang="it-IT" sz="1200" b="1" dirty="0">
                 <a:solidFill>
                   <a:srgbClr val="FF0000"/>
                 </a:solidFill>
@@ -12284,17 +12513,8 @@
               <a:rPr lang="it-IT" sz="1200" dirty="0">
                 <a:latin typeface="+mj-lt"/>
               </a:rPr>
-              <a:t>   = base-</a:t>
-            </a:r>
-            <a:r>
-              <a:rPr lang="it-IT" sz="1200" dirty="0" err="1">
-                <a:latin typeface="+mj-lt"/>
-              </a:rPr>
-              <a:t>small.eap</a:t>
-            </a:r>
-            <a:endParaRPr lang="it-IT" sz="1200" dirty="0">
-              <a:latin typeface="+mj-lt"/>
-            </a:endParaRPr>
+              <a:t>   = base-small.qea</a:t>
+            </a:r>
           </a:p>
         </p:txBody>
       </p:sp>
@@ -12346,7 +12566,7 @@
         <p:spPr bwMode="auto">
           <a:xfrm>
             <a:off x="5904925" y="4725144"/>
-            <a:ext cx="2957676" cy="369332"/>
+            <a:ext cx="2957676" cy="380297"/>
           </a:xfrm>
           <a:prstGeom prst="rect">
             <a:avLst/>
@@ -12376,7 +12596,7 @@
               </a:spcBef>
             </a:pPr>
             <a:r>
-              <a:rPr lang="it-IT" sz="1200" b="1" dirty="0" err="1">
+              <a:rPr lang="it-IT" sz="1200" b="1" dirty="0">
                 <a:solidFill>
                   <a:srgbClr val="FF0000"/>
                 </a:solidFill>
@@ -12388,17 +12608,8 @@
               <a:rPr lang="it-IT" sz="1200" dirty="0">
                 <a:latin typeface="+mj-lt"/>
               </a:rPr>
-              <a:t>   = base-</a:t>
-            </a:r>
-            <a:r>
-              <a:rPr lang="it-IT" sz="1200" dirty="0" err="1">
-                <a:latin typeface="+mj-lt"/>
-              </a:rPr>
-              <a:t>small.eap</a:t>
-            </a:r>
-            <a:endParaRPr lang="it-IT" sz="1200" dirty="0">
-              <a:latin typeface="+mj-lt"/>
-            </a:endParaRPr>
+              <a:t>   = base-small.qea</a:t>
+            </a:r>
           </a:p>
           <a:p>
             <a:pPr>
@@ -12447,7 +12658,7 @@
         <p:spPr bwMode="auto">
           <a:xfrm>
             <a:off x="5902583" y="5373685"/>
-            <a:ext cx="2957676" cy="369332"/>
+            <a:ext cx="2957676" cy="380425"/>
           </a:xfrm>
           <a:prstGeom prst="rect">
             <a:avLst/>
@@ -12477,7 +12688,7 @@
               </a:spcBef>
             </a:pPr>
             <a:r>
-              <a:rPr lang="it-IT" sz="1200" b="1" dirty="0" err="1">
+              <a:rPr lang="it-IT" sz="1200" b="1" dirty="0">
                 <a:solidFill>
                   <a:srgbClr val="FF0000"/>
                 </a:solidFill>
@@ -12489,17 +12700,8 @@
               <a:rPr lang="it-IT" sz="1200" dirty="0">
                 <a:latin typeface="+mj-lt"/>
               </a:rPr>
-              <a:t>   = base-</a:t>
-            </a:r>
-            <a:r>
-              <a:rPr lang="it-IT" sz="1200" dirty="0" err="1">
-                <a:latin typeface="+mj-lt"/>
-              </a:rPr>
-              <a:t>small.eap</a:t>
-            </a:r>
-            <a:endParaRPr lang="it-IT" sz="1200" dirty="0">
-              <a:latin typeface="+mj-lt"/>
-            </a:endParaRPr>
+              <a:t>   = base-small.qea</a:t>
+            </a:r>
           </a:p>
           <a:p>
             <a:pPr>
@@ -12781,9 +12983,9 @@
         <p:grpSpPr>
           <a:xfrm>
             <a:off x="5810081" y="3800991"/>
-            <a:ext cx="3050177" cy="637746"/>
+            <a:ext cx="3050177" cy="648839"/>
             <a:chOff x="4241141" y="2530544"/>
-            <a:chExt cx="3355195" cy="637746"/>
+            <a:chExt cx="3355195" cy="648839"/>
           </a:xfrm>
         </p:grpSpPr>
         <p:sp>
@@ -12797,7 +12999,7 @@
           <p:spPr bwMode="auto">
             <a:xfrm>
               <a:off x="4342892" y="2798958"/>
-              <a:ext cx="3253444" cy="369332"/>
+              <a:ext cx="3253444" cy="380425"/>
             </a:xfrm>
             <a:prstGeom prst="rect">
               <a:avLst/>
@@ -12827,7 +13029,7 @@
                 </a:spcBef>
               </a:pPr>
               <a:r>
-                <a:rPr lang="it-IT" sz="1200" b="1" dirty="0" err="1">
+                <a:rPr lang="it-IT" sz="1200" b="1" dirty="0">
                   <a:solidFill>
                     <a:srgbClr val="FF0000"/>
                   </a:solidFill>
@@ -12839,17 +13041,8 @@
                 <a:rPr lang="it-IT" sz="1200" dirty="0">
                   <a:latin typeface="+mj-lt"/>
                 </a:rPr>
-                <a:t>   = base-</a:t>
+                <a:t>   = base-small.qea</a:t>
               </a:r>
-              <a:r>
-                <a:rPr lang="it-IT" sz="1200" dirty="0" err="1">
-                  <a:latin typeface="+mj-lt"/>
-                </a:rPr>
-                <a:t>small.eap</a:t>
-              </a:r>
-              <a:endParaRPr lang="it-IT" sz="1200" dirty="0">
-                <a:latin typeface="+mj-lt"/>
-              </a:endParaRPr>
             </a:p>
             <a:p>
               <a:pPr>
@@ -16578,7 +16771,7 @@
                   <a:schemeClr val="tx2"/>
                 </a:solidFill>
               </a:rPr>
-              <a:t>, and .</a:t>
+              <a:t> and .</a:t>
             </a:r>
             <a:r>
               <a:rPr lang="en-US" sz="2000" dirty="0" err="1">
@@ -16649,7 +16842,7 @@
         <p:spPr bwMode="auto">
           <a:xfrm>
             <a:off x="927152" y="4922584"/>
-            <a:ext cx="3253444" cy="738664"/>
+            <a:ext cx="3253444" cy="749629"/>
           </a:xfrm>
           <a:prstGeom prst="rect">
             <a:avLst/>
@@ -16679,26 +16872,11 @@
               </a:spcBef>
             </a:pPr>
             <a:r>
-              <a:rPr lang="it-IT" sz="1200" dirty="0" err="1">
-                <a:latin typeface="+mj-lt"/>
-              </a:rPr>
-              <a:t>model.filename</a:t>
-            </a:r>
-            <a:r>
               <a:rPr lang="it-IT" sz="1200" dirty="0">
                 <a:latin typeface="+mj-lt"/>
               </a:rPr>
-              <a:t>   = base-</a:t>
-            </a:r>
-            <a:r>
-              <a:rPr lang="it-IT" sz="1200" dirty="0" err="1">
-                <a:latin typeface="+mj-lt"/>
-              </a:rPr>
-              <a:t>small.eap</a:t>
-            </a:r>
-            <a:endParaRPr lang="it-IT" sz="1200" dirty="0">
-              <a:latin typeface="+mj-lt"/>
-            </a:endParaRPr>
+              <a:t>model.filename   = base-small.qea</a:t>
+            </a:r>
           </a:p>
           <a:p>
             <a:pPr>
@@ -17019,7 +17197,19 @@
                   <a:schemeClr val="tx2"/>
                 </a:solidFill>
               </a:rPr>
-              <a:t> or .</a:t>
+              <a:t> </a:t>
+            </a:r>
+            <a:r>
+              <a:rPr lang="en-US" sz="2000" dirty="0"/>
+              <a:t>or</a:t>
+            </a:r>
+            <a:r>
+              <a:rPr lang="en-US" sz="2000" dirty="0">
+                <a:solidFill>
+                  <a:schemeClr val="tx2"/>
+                </a:solidFill>
+              </a:rPr>
+              <a:t> .</a:t>
             </a:r>
             <a:r>
               <a:rPr lang="en-US" sz="2000" dirty="0" err="1">
@@ -17338,7 +17528,7 @@
         <p:spPr bwMode="auto">
           <a:xfrm>
             <a:off x="5142701" y="1916832"/>
-            <a:ext cx="3253444" cy="923330"/>
+            <a:ext cx="3253444" cy="934295"/>
           </a:xfrm>
           <a:prstGeom prst="rect">
             <a:avLst/>
@@ -17368,26 +17558,11 @@
               </a:spcBef>
             </a:pPr>
             <a:r>
-              <a:rPr lang="it-IT" sz="1200" dirty="0" err="1">
-                <a:latin typeface="+mj-lt"/>
-              </a:rPr>
-              <a:t>model.filename</a:t>
-            </a:r>
-            <a:r>
               <a:rPr lang="it-IT" sz="1200" dirty="0">
                 <a:latin typeface="+mj-lt"/>
               </a:rPr>
-              <a:t>     = base-</a:t>
-            </a:r>
-            <a:r>
-              <a:rPr lang="it-IT" sz="1200" dirty="0" err="1">
-                <a:latin typeface="+mj-lt"/>
-              </a:rPr>
-              <a:t>small.eap</a:t>
-            </a:r>
-            <a:endParaRPr lang="it-IT" sz="1200" dirty="0">
-              <a:latin typeface="+mj-lt"/>
-            </a:endParaRPr>
+              <a:t>model.filename     = base-small.qea</a:t>
+            </a:r>
           </a:p>
           <a:p>
             <a:pPr>
@@ -17734,7 +17909,7 @@
         <p:spPr bwMode="auto">
           <a:xfrm>
             <a:off x="5121882" y="3771147"/>
-            <a:ext cx="3842607" cy="1015663"/>
+            <a:ext cx="3842607" cy="934295"/>
           </a:xfrm>
           <a:prstGeom prst="rect">
             <a:avLst/>
@@ -17764,26 +17939,11 @@
               </a:spcBef>
             </a:pPr>
             <a:r>
-              <a:rPr lang="it-IT" sz="1200" dirty="0" err="1">
-                <a:latin typeface="+mj-lt"/>
-              </a:rPr>
-              <a:t>model.filename</a:t>
-            </a:r>
-            <a:r>
               <a:rPr lang="it-IT" sz="1200" dirty="0">
                 <a:latin typeface="+mj-lt"/>
               </a:rPr>
-              <a:t>     = base-</a:t>
-            </a:r>
-            <a:r>
-              <a:rPr lang="it-IT" sz="1200" dirty="0" err="1">
-                <a:latin typeface="+mj-lt"/>
-              </a:rPr>
-              <a:t>small.eap</a:t>
-            </a:r>
-            <a:endParaRPr lang="it-IT" sz="1200" dirty="0">
-              <a:latin typeface="+mj-lt"/>
-            </a:endParaRPr>
+              <a:t>model.filename     = base-small.qea</a:t>
+            </a:r>
           </a:p>
           <a:p>
             <a:pPr>
@@ -18694,7 +18854,7 @@
         <p:spPr bwMode="auto">
           <a:xfrm>
             <a:off x="903754" y="4509120"/>
-            <a:ext cx="3253444" cy="553998"/>
+            <a:ext cx="3253444" cy="564963"/>
           </a:xfrm>
           <a:prstGeom prst="rect">
             <a:avLst/>
@@ -18724,26 +18884,11 @@
               </a:spcBef>
             </a:pPr>
             <a:r>
-              <a:rPr lang="it-IT" sz="1200" dirty="0" err="1">
-                <a:latin typeface="+mj-lt"/>
-              </a:rPr>
-              <a:t>model.filename</a:t>
-            </a:r>
-            <a:r>
               <a:rPr lang="it-IT" sz="1200" dirty="0">
                 <a:latin typeface="+mj-lt"/>
               </a:rPr>
-              <a:t>   = base-</a:t>
-            </a:r>
-            <a:r>
-              <a:rPr lang="it-IT" sz="1200" dirty="0" err="1">
-                <a:latin typeface="+mj-lt"/>
-              </a:rPr>
-              <a:t>small.eap</a:t>
-            </a:r>
-            <a:endParaRPr lang="it-IT" sz="1200" dirty="0">
-              <a:latin typeface="+mj-lt"/>
-            </a:endParaRPr>
+              <a:t>model.filename   = base-small.qea</a:t>
+            </a:r>
           </a:p>
           <a:p>
             <a:pPr>
@@ -25133,7 +25278,7 @@
         <p:spPr/>
         <p:txBody>
           <a:bodyPr>
-            <a:normAutofit fontScale="92500"/>
+            <a:normAutofit fontScale="92500" lnSpcReduction="10000"/>
           </a:bodyPr>
           <a:lstStyle/>
           <a:p>
@@ -25142,7 +25287,51 @@
             </a:pPr>
             <a:r>
               <a:rPr lang="en-GB" sz="2000" dirty="0"/>
-              <a:t>Extract from validation log with base-small.eap UML model</a:t>
+              <a:t>Extract from validation log with </a:t>
+            </a:r>
+            <a:r>
+              <a:rPr lang="en-GB" sz="2000" dirty="0">
+                <a:solidFill>
+                  <a:schemeClr val="tx2"/>
+                </a:solidFill>
+              </a:rPr>
+              <a:t>base-</a:t>
+            </a:r>
+            <a:r>
+              <a:rPr lang="en-GB" sz="2000" dirty="0" err="1">
+                <a:solidFill>
+                  <a:schemeClr val="tx2"/>
+                </a:solidFill>
+              </a:rPr>
+              <a:t>small.eap</a:t>
+            </a:r>
+            <a:r>
+              <a:rPr lang="en-GB" sz="2000" dirty="0">
+                <a:solidFill>
+                  <a:schemeClr val="tx2"/>
+                </a:solidFill>
+              </a:rPr>
+              <a:t>/base-</a:t>
+            </a:r>
+            <a:r>
+              <a:rPr lang="en-GB" sz="2000" dirty="0" err="1">
+                <a:solidFill>
+                  <a:schemeClr val="tx2"/>
+                </a:solidFill>
+              </a:rPr>
+              <a:t>small.qea</a:t>
+            </a:r>
+            <a:r>
+              <a:rPr lang="en-GB" sz="2000" dirty="0">
+                <a:solidFill>
+                  <a:schemeClr val="tx2"/>
+                </a:solidFill>
+              </a:rPr>
+              <a:t> </a:t>
+            </a:r>
+            <a:r>
+              <a:rPr lang="en-GB" sz="2000" dirty="0"/>
+              <a:t>UML model</a:t>
             </a:r>
           </a:p>
           <a:p>
@@ -25350,7 +25539,7 @@
         </p:nvGrpSpPr>
         <p:grpSpPr>
           <a:xfrm>
-            <a:off x="398583" y="2618427"/>
+            <a:off x="292337" y="2852936"/>
             <a:ext cx="8745417" cy="1444057"/>
             <a:chOff x="246184" y="4452943"/>
             <a:chExt cx="8745417" cy="1444057"/>
@@ -25863,26 +26052,11 @@
               </a:spcBef>
             </a:pPr>
             <a:r>
-              <a:rPr lang="it-IT" sz="1200" dirty="0" err="1">
-                <a:latin typeface="+mj-lt"/>
-              </a:rPr>
-              <a:t>model.filename</a:t>
-            </a:r>
-            <a:r>
               <a:rPr lang="it-IT" sz="1200" dirty="0">
                 <a:latin typeface="+mj-lt"/>
               </a:rPr>
-              <a:t>       = base-</a:t>
-            </a:r>
-            <a:r>
-              <a:rPr lang="it-IT" sz="1200" dirty="0" err="1">
-                <a:latin typeface="+mj-lt"/>
-              </a:rPr>
-              <a:t>small.eap</a:t>
-            </a:r>
-            <a:endParaRPr lang="it-IT" sz="1200" dirty="0">
-              <a:latin typeface="+mj-lt"/>
-            </a:endParaRPr>
+              <a:t>model.filename       = base-small.qea</a:t>
+            </a:r>
           </a:p>
           <a:p>
             <a:pPr>
@@ -26643,7 +26817,7 @@
         <p:spPr bwMode="auto">
           <a:xfrm>
             <a:off x="827285" y="4576296"/>
-            <a:ext cx="3253444" cy="553998"/>
+            <a:ext cx="3253444" cy="564963"/>
           </a:xfrm>
           <a:prstGeom prst="rect">
             <a:avLst/>
@@ -26673,26 +26847,11 @@
               </a:spcBef>
             </a:pPr>
             <a:r>
-              <a:rPr lang="it-IT" sz="1200" dirty="0" err="1">
-                <a:latin typeface="+mj-lt"/>
-              </a:rPr>
-              <a:t>model.filename</a:t>
-            </a:r>
-            <a:r>
               <a:rPr lang="it-IT" sz="1200" dirty="0">
                 <a:latin typeface="+mj-lt"/>
               </a:rPr>
-              <a:t>   = base-</a:t>
-            </a:r>
-            <a:r>
-              <a:rPr lang="it-IT" sz="1200" dirty="0" err="1">
-                <a:latin typeface="+mj-lt"/>
-              </a:rPr>
-              <a:t>small.eap</a:t>
-            </a:r>
-            <a:endParaRPr lang="it-IT" sz="1200" dirty="0">
-              <a:latin typeface="+mj-lt"/>
-            </a:endParaRPr>
+              <a:t>model.filename   = base-small.qea</a:t>
+            </a:r>
           </a:p>
           <a:p>
             <a:pPr>
@@ -27415,7 +27574,43 @@
             </a:pPr>
             <a:r>
               <a:rPr lang="en-GB" sz="2000" dirty="0"/>
-              <a:t>Example of CIM-specific constructs from base-small.eap:</a:t>
+              <a:t>Example of CIM-specific constructs from </a:t>
+            </a:r>
+            <a:r>
+              <a:rPr lang="en-GB" sz="2000" dirty="0">
+                <a:solidFill>
+                  <a:schemeClr val="tx2"/>
+                </a:solidFill>
+              </a:rPr>
+              <a:t>base-</a:t>
+            </a:r>
+            <a:r>
+              <a:rPr lang="en-GB" sz="2000" dirty="0" err="1">
+                <a:solidFill>
+                  <a:schemeClr val="tx2"/>
+                </a:solidFill>
+              </a:rPr>
+              <a:t>small.eap</a:t>
+            </a:r>
+            <a:r>
+              <a:rPr lang="en-GB" sz="2000" dirty="0">
+                <a:solidFill>
+                  <a:schemeClr val="tx2"/>
+                </a:solidFill>
+              </a:rPr>
+              <a:t>/base-</a:t>
+            </a:r>
+            <a:r>
+              <a:rPr lang="en-GB" sz="2000" dirty="0" err="1">
+                <a:solidFill>
+                  <a:schemeClr val="tx2"/>
+                </a:solidFill>
+              </a:rPr>
+              <a:t>small.qea</a:t>
+            </a:r>
+            <a:r>
+              <a:rPr lang="en-GB" sz="2000" dirty="0"/>
+              <a:t>:</a:t>
             </a:r>
           </a:p>
           <a:p>
@@ -27644,8 +27839,8 @@
         </p:nvSpPr>
         <p:spPr>
           <a:xfrm>
-            <a:off x="457200" y="1600200"/>
-            <a:ext cx="2386608" cy="4525963"/>
+            <a:off x="457199" y="1600200"/>
+            <a:ext cx="2479801" cy="4525963"/>
           </a:xfrm>
         </p:spPr>
         <p:txBody>
@@ -27659,7 +27854,51 @@
             </a:pPr>
             <a:r>
               <a:rPr lang="en-GB" sz="2000" dirty="0"/>
-              <a:t>Example of IEC 61850-specific constructs from base-small.eap:</a:t>
+              <a:t>Example of IEC 61850-specific constructs from </a:t>
+            </a:r>
+            <a:r>
+              <a:rPr lang="en-GB" sz="2000" dirty="0">
+                <a:solidFill>
+                  <a:schemeClr val="tx2"/>
+                </a:solidFill>
+              </a:rPr>
+              <a:t>base-</a:t>
+            </a:r>
+            <a:r>
+              <a:rPr lang="en-GB" sz="2000" dirty="0" err="1">
+                <a:solidFill>
+                  <a:schemeClr val="tx2"/>
+                </a:solidFill>
+              </a:rPr>
+              <a:t>small.eap</a:t>
+            </a:r>
+            <a:r>
+              <a:rPr lang="en-GB" sz="2000" dirty="0">
+                <a:solidFill>
+                  <a:schemeClr val="tx2"/>
+                </a:solidFill>
+              </a:rPr>
+              <a:t>/base-</a:t>
+            </a:r>
+            <a:r>
+              <a:rPr lang="en-GB" sz="2000" dirty="0" err="1">
+                <a:solidFill>
+                  <a:schemeClr val="tx2"/>
+                </a:solidFill>
+              </a:rPr>
+              <a:t>small.qea</a:t>
+            </a:r>
+            <a:r>
+              <a:rPr lang="en-GB" sz="2000" dirty="0">
+                <a:solidFill>
+                  <a:schemeClr val="tx2"/>
+                </a:solidFill>
+              </a:rPr>
+              <a:t> </a:t>
+            </a:r>
+            <a:r>
+              <a:rPr lang="en-GB" sz="2000" dirty="0"/>
+              <a:t>:</a:t>
             </a:r>
           </a:p>
           <a:p>
@@ -28378,8 +28617,24 @@
               <a:t>In-memory representation of the UML from .</a:t>
             </a:r>
             <a:r>
-              <a:rPr lang="en-GB" dirty="0" err="1"/>
+              <a:rPr lang="en-GB" dirty="0" err="1">
+                <a:solidFill>
+                  <a:schemeClr val="tx2"/>
+                </a:solidFill>
+              </a:rPr>
               <a:t>eap</a:t>
+            </a:r>
+            <a:r>
+              <a:rPr lang="en-GB" dirty="0"/>
+              <a:t> or .</a:t>
+            </a:r>
+            <a:r>
+              <a:rPr lang="en-GB" dirty="0" err="1">
+                <a:solidFill>
+                  <a:schemeClr val="tx2"/>
+                </a:solidFill>
+              </a:rPr>
+              <a:t>qea</a:t>
             </a:r>
             <a:r>
               <a:rPr lang="en-GB" dirty="0"/>
@@ -29567,7 +29822,7 @@
                   </a:solidFill>
                   <a:latin typeface="+mj-lt"/>
                 </a:rPr>
-                <a:t>small.eap</a:t>
+                <a:t>small.qea</a:t>
               </a:r>
               <a:endParaRPr lang="it-IT" sz="1200" dirty="0">
                 <a:latin typeface="+mj-lt"/>
@@ -34588,7 +34843,7 @@
         <p:spPr>
           <a:xfrm>
             <a:off x="457199" y="1600200"/>
-            <a:ext cx="3896205" cy="4525963"/>
+            <a:ext cx="3896205" cy="4853136"/>
           </a:xfrm>
           <a:noFill/>
         </p:spPr>
@@ -34633,7 +34888,51 @@
             <a:pPr marL="176213" lvl="1" indent="-163513" eaLnBrk="1" hangingPunct="1"/>
             <a:r>
               <a:rPr lang="en-GB" sz="1200" dirty="0"/>
-              <a:t>From base-small.eap example: attribute </a:t>
+              <a:t>From </a:t>
+            </a:r>
+            <a:r>
+              <a:rPr lang="en-GB" sz="1200" dirty="0">
+                <a:solidFill>
+                  <a:schemeClr val="tx2"/>
+                </a:solidFill>
+              </a:rPr>
+              <a:t>base-</a:t>
+            </a:r>
+            <a:r>
+              <a:rPr lang="en-GB" sz="1200" dirty="0" err="1">
+                <a:solidFill>
+                  <a:schemeClr val="tx2"/>
+                </a:solidFill>
+              </a:rPr>
+              <a:t>small.eap</a:t>
+            </a:r>
+            <a:r>
+              <a:rPr lang="en-GB" sz="1200" dirty="0">
+                <a:solidFill>
+                  <a:schemeClr val="tx2"/>
+                </a:solidFill>
+              </a:rPr>
+              <a:t>/base-</a:t>
+            </a:r>
+            <a:r>
+              <a:rPr lang="en-GB" sz="1200" dirty="0" err="1">
+                <a:solidFill>
+                  <a:schemeClr val="tx2"/>
+                </a:solidFill>
+              </a:rPr>
+              <a:t>small.qea</a:t>
+            </a:r>
+            <a:r>
+              <a:rPr lang="en-GB" sz="1200" dirty="0">
+                <a:solidFill>
+                  <a:schemeClr val="tx2"/>
+                </a:solidFill>
+              </a:rPr>
+              <a:t> </a:t>
+            </a:r>
+            <a:r>
+              <a:rPr lang="en-GB" sz="1200" dirty="0"/>
+              <a:t>example: attribute </a:t>
             </a:r>
             <a:r>
               <a:rPr lang="en-GB" sz="1200" b="1" dirty="0" err="1"/>
@@ -34698,7 +34997,51 @@
             <a:pPr marL="176213" lvl="1" indent="-163513" eaLnBrk="1" hangingPunct="1"/>
             <a:r>
               <a:rPr lang="en-GB" sz="1200" dirty="0"/>
-              <a:t>For this base-small.eap example, we have set </a:t>
+              <a:t>For this </a:t>
+            </a:r>
+            <a:r>
+              <a:rPr lang="en-GB" sz="1200" dirty="0">
+                <a:solidFill>
+                  <a:schemeClr val="tx2"/>
+                </a:solidFill>
+              </a:rPr>
+              <a:t>base-</a:t>
+            </a:r>
+            <a:r>
+              <a:rPr lang="en-GB" sz="1200" dirty="0" err="1">
+                <a:solidFill>
+                  <a:schemeClr val="tx2"/>
+                </a:solidFill>
+              </a:rPr>
+              <a:t>small.eap</a:t>
+            </a:r>
+            <a:r>
+              <a:rPr lang="en-GB" sz="1200" dirty="0">
+                <a:solidFill>
+                  <a:schemeClr val="tx2"/>
+                </a:solidFill>
+              </a:rPr>
+              <a:t>/base-</a:t>
+            </a:r>
+            <a:r>
+              <a:rPr lang="en-GB" sz="1200" dirty="0" err="1">
+                <a:solidFill>
+                  <a:schemeClr val="tx2"/>
+                </a:solidFill>
+              </a:rPr>
+              <a:t>small.qea</a:t>
+            </a:r>
+            <a:r>
+              <a:rPr lang="en-GB" sz="1200" dirty="0">
+                <a:solidFill>
+                  <a:schemeClr val="tx2"/>
+                </a:solidFill>
+              </a:rPr>
+              <a:t> </a:t>
+            </a:r>
+            <a:r>
+              <a:rPr lang="en-GB" sz="1200" dirty="0"/>
+              <a:t>example, we have set </a:t>
             </a:r>
             <a:r>
               <a:rPr lang="en-GB" sz="1200" dirty="0" err="1"/>
@@ -38550,15 +38893,11 @@
                   <a:schemeClr val="tx2"/>
                 </a:solidFill>
               </a:rPr>
-              <a:t> &amp; .</a:t>
-            </a:r>
-            <a:r>
-              <a:rPr lang="en-GB" sz="1800" dirty="0" err="1">
-                <a:solidFill>
-                  <a:schemeClr val="tx2"/>
-                </a:solidFill>
-              </a:rPr>
-              <a:t>eapx</a:t>
+              <a:t> </a:t>
+            </a:r>
+            <a:r>
+              <a:rPr lang="en-GB" sz="1800" dirty="0"/>
+              <a:t>projects</a:t>
             </a:r>
             <a:endParaRPr lang="en-GB" sz="1800" dirty="0">
               <a:solidFill>
@@ -38888,15 +39227,11 @@
                   <a:schemeClr val="tx2"/>
                 </a:solidFill>
               </a:rPr>
-              <a:t> &amp; .</a:t>
-            </a:r>
-            <a:r>
-              <a:rPr lang="en-GB" sz="1800" dirty="0" err="1">
-                <a:solidFill>
-                  <a:schemeClr val="tx2"/>
-                </a:solidFill>
-              </a:rPr>
-              <a:t>qeax</a:t>
+              <a:t> </a:t>
+            </a:r>
+            <a:r>
+              <a:rPr lang="en-GB" sz="1800" dirty="0"/>
+              <a:t>projects</a:t>
             </a:r>
             <a:endParaRPr lang="en-GB" sz="1800" dirty="0">
               <a:solidFill>
@@ -39465,15 +39800,63 @@
             </a:pPr>
             <a:r>
               <a:rPr lang="en-GB" dirty="0"/>
-              <a:t>It is also detached from the .</a:t>
-            </a:r>
-            <a:r>
-              <a:rPr lang="en-GB" dirty="0" err="1"/>
+              <a:t>It is also detached from the </a:t>
+            </a:r>
+            <a:r>
+              <a:rPr lang="en-GB" dirty="0">
+                <a:solidFill>
+                  <a:schemeClr val="tx2"/>
+                </a:solidFill>
+              </a:rPr>
+              <a:t>.</a:t>
+            </a:r>
+            <a:r>
+              <a:rPr lang="en-GB" dirty="0" err="1">
+                <a:solidFill>
+                  <a:schemeClr val="tx2"/>
+                </a:solidFill>
+              </a:rPr>
               <a:t>eap</a:t>
             </a:r>
             <a:r>
+              <a:rPr lang="en-GB" dirty="0">
+                <a:solidFill>
+                  <a:schemeClr val="tx2"/>
+                </a:solidFill>
+              </a:rPr>
+              <a:t> </a:t>
+            </a:r>
+            <a:r>
               <a:rPr lang="en-GB" dirty="0"/>
-              <a:t> file</a:t>
+              <a:t>or </a:t>
+            </a:r>
+            <a:r>
+              <a:rPr lang="en-GB" dirty="0">
+                <a:solidFill>
+                  <a:schemeClr val="tx2"/>
+                </a:solidFill>
+              </a:rPr>
+              <a:t>.</a:t>
+            </a:r>
+            <a:r>
+              <a:rPr lang="en-GB" dirty="0" err="1">
+                <a:solidFill>
+                  <a:schemeClr val="tx2"/>
+                </a:solidFill>
+              </a:rPr>
+              <a:t>qea</a:t>
+            </a:r>
+            <a:r>
+              <a:rPr lang="en-GB" dirty="0">
+                <a:solidFill>
+                  <a:schemeClr val="tx2"/>
+                </a:solidFill>
+              </a:rPr>
+              <a:t> </a:t>
+            </a:r>
+            <a:r>
+              <a:rPr lang="en-GB" dirty="0"/>
+              <a:t>file</a:t>
             </a:r>
           </a:p>
           <a:p>
@@ -40092,7 +40475,7 @@
               <a:rPr lang="en-GB" sz="1200" dirty="0" err="1">
                 <a:latin typeface="+mj-lt"/>
               </a:rPr>
-              <a:t>small.eap</a:t>
+              <a:t>small.qea</a:t>
             </a:r>
             <a:endParaRPr lang="it-IT" sz="1200" dirty="0">
               <a:latin typeface="+mj-lt"/>
@@ -46970,12 +47353,65 @@
               <a:rPr lang="en-US" sz="1800" dirty="0"/>
               <a:t>EA16.x 64-bit releases require a 64-bit Java JRE/JDK</a:t>
             </a:r>
-            <a:endParaRPr lang="en-GB" sz="1800" dirty="0">
+          </a:p>
+          <a:p>
+            <a:pPr marL="269875" lvl="1" indent="-257175"/>
+            <a:endParaRPr lang="en-US" sz="1800" dirty="0">
               <a:solidFill>
                 <a:prstClr val="black">
                   <a:lumMod val="50000"/>
                   <a:lumOff val="50000"/>
                 </a:prstClr>
+              </a:solidFill>
+            </a:endParaRPr>
+          </a:p>
+          <a:p>
+            <a:pPr marL="12700" lvl="1" indent="0">
+              <a:buNone/>
+            </a:pPr>
+            <a:r>
+              <a:rPr lang="en-US" sz="1800" dirty="0">
+                <a:solidFill>
+                  <a:srgbClr val="FF0000"/>
+                </a:solidFill>
+              </a:rPr>
+              <a:t>IMPORTANT:  When working with .</a:t>
+            </a:r>
+            <a:r>
+              <a:rPr lang="en-US" sz="1800" dirty="0" err="1">
+                <a:solidFill>
+                  <a:srgbClr val="FF0000"/>
+                </a:solidFill>
+              </a:rPr>
+              <a:t>eap</a:t>
+            </a:r>
+            <a:r>
+              <a:rPr lang="en-US" sz="1800" dirty="0">
+                <a:solidFill>
+                  <a:srgbClr val="FF0000"/>
+                </a:solidFill>
+              </a:rPr>
+              <a:t> project files you must use the 32-bit distribution. Likewise, when working with .</a:t>
+            </a:r>
+            <a:r>
+              <a:rPr lang="en-US" sz="1800" dirty="0" err="1">
+                <a:solidFill>
+                  <a:srgbClr val="FF0000"/>
+                </a:solidFill>
+              </a:rPr>
+              <a:t>qea</a:t>
+            </a:r>
+            <a:r>
+              <a:rPr lang="en-US" sz="1800" dirty="0">
+                <a:solidFill>
+                  <a:srgbClr val="FF0000"/>
+                </a:solidFill>
+              </a:rPr>
+              <a:t> project files the 64-bit distribution must be used.</a:t>
+            </a:r>
+            <a:endParaRPr lang="en-GB" sz="1800" dirty="0">
+              <a:solidFill>
+                <a:srgbClr val="FF0000"/>
               </a:solidFill>
             </a:endParaRPr>
           </a:p>

</xml_diff>

<commit_message>
Updated presentation for the new release.
</commit_message>
<xml_diff>
--- a/doc/jCleanCimIntro.pptx
+++ b/doc/jCleanCimIntro.pptx
@@ -19059,13 +19059,6 @@
             </a:r>
             <a:endParaRPr lang="en-GB" b="1" dirty="0"/>
           </a:p>
-          <a:p>
-            <a:pPr marL="685800" lvl="2"/>
-            <a:r>
-              <a:rPr lang="en-GB" dirty="0"/>
-              <a:t>Javadoc also contains UML for all the classes (not shown below)</a:t>
-            </a:r>
-          </a:p>
         </p:txBody>
       </p:sp>
       <p:sp>
@@ -33506,8 +33499,8 @@
         </p:blipFill>
         <p:spPr bwMode="auto">
           <a:xfrm>
-            <a:off x="5506550" y="3613098"/>
-            <a:ext cx="3180250" cy="2058112"/>
+            <a:off x="5508104" y="3645023"/>
+            <a:ext cx="3222416" cy="2481139"/>
           </a:xfrm>
           <a:prstGeom prst="rect">
             <a:avLst/>
@@ -33544,8 +33537,8 @@
         </p:blipFill>
         <p:spPr bwMode="auto">
           <a:xfrm>
-            <a:off x="5498281" y="1786353"/>
-            <a:ext cx="3243246" cy="1233210"/>
+            <a:off x="5508104" y="1786352"/>
+            <a:ext cx="3223016" cy="1575429"/>
           </a:xfrm>
           <a:prstGeom prst="rect">
             <a:avLst/>
@@ -33696,42 +33689,14 @@
             </a:r>
           </a:p>
           <a:p>
-            <a:pPr marL="285750" lvl="1" eaLnBrk="1" hangingPunct="1">
+            <a:pPr marL="285750" lvl="1">
               <a:lnSpc>
                 <a:spcPct val="90000"/>
               </a:lnSpc>
             </a:pPr>
             <a:r>
-              <a:rPr lang="en-GB" sz="1600" dirty="0"/>
-              <a:t>For binary distributions</a:t>
-            </a:r>
-            <a:r>
               <a:rPr lang="en-GB" dirty="0"/>
-              <a:t> it </a:t>
-            </a:r>
-            <a:r>
-              <a:rPr lang="en-GB" sz="1600" dirty="0"/>
-              <a:t>additionally ships as a </a:t>
-            </a:r>
-            <a:r>
-              <a:rPr lang="en-GB" sz="1600" dirty="0">
-                <a:solidFill>
-                  <a:srgbClr val="FF0000"/>
-                </a:solidFill>
-              </a:rPr>
-              <a:t>.pdf </a:t>
-            </a:r>
-            <a:r>
-              <a:rPr lang="en-GB" sz="1600" dirty="0"/>
-              <a:t>(auto-generated from the </a:t>
-            </a:r>
-            <a:r>
-              <a:rPr lang="en-GB" sz="1600" dirty="0" err="1"/>
-              <a:t>javadoc</a:t>
-            </a:r>
-            <a:r>
-              <a:rPr lang="en-GB" sz="1600" dirty="0"/>
-              <a:t>)</a:t>
+              <a:t>For source distribution, also build targets dependencies</a:t>
             </a:r>
           </a:p>
         </p:txBody>
@@ -33772,8 +33737,8 @@
         </p:nvSpPr>
         <p:spPr bwMode="auto">
           <a:xfrm flipV="1">
-            <a:off x="4427984" y="2132856"/>
-            <a:ext cx="3096344" cy="2052940"/>
+            <a:off x="4427984" y="1988840"/>
+            <a:ext cx="2808312" cy="2196956"/>
           </a:xfrm>
           <a:prstGeom prst="line">
             <a:avLst/>
@@ -33839,9 +33804,9 @@
           <p:nvPr/>
         </p:nvSpPr>
         <p:spPr bwMode="auto">
-          <a:xfrm flipV="1">
-            <a:off x="4499992" y="2579204"/>
-            <a:ext cx="3024334" cy="1857908"/>
+          <a:xfrm>
+            <a:off x="3923928" y="2243483"/>
+            <a:ext cx="3240360" cy="393429"/>
           </a:xfrm>
           <a:prstGeom prst="line">
             <a:avLst/>
@@ -33965,8 +33930,8 @@
         </p:nvSpPr>
         <p:spPr bwMode="auto">
           <a:xfrm>
-            <a:off x="5652120" y="1738122"/>
-            <a:ext cx="1342356" cy="308426"/>
+            <a:off x="5575107" y="1738122"/>
+            <a:ext cx="1008112" cy="308426"/>
           </a:xfrm>
           <a:prstGeom prst="ellipse">
             <a:avLst/>
@@ -33983,6 +33948,86 @@
         </p:spPr>
         <p:txBody>
           <a:bodyPr wrap="none" anchor="ctr"/>
+          <a:lstStyle/>
+          <a:p>
+            <a:endParaRPr lang="en-US"/>
+          </a:p>
+        </p:txBody>
+      </p:sp>
+      <p:sp>
+        <p:nvSpPr>
+          <p:cNvPr id="7" name="Line 12">
+            <a:extLst>
+              <a:ext uri="{FF2B5EF4-FFF2-40B4-BE49-F238E27FC236}">
+                <a16:creationId xmlns:a16="http://schemas.microsoft.com/office/drawing/2014/main" id="{937997F5-12C9-0E93-D908-6033B7FC9B68}"/>
+              </a:ext>
+            </a:extLst>
+          </p:cNvPr>
+          <p:cNvSpPr>
+            <a:spLocks noChangeShapeType="1"/>
+          </p:cNvSpPr>
+          <p:nvPr/>
+        </p:nvSpPr>
+        <p:spPr bwMode="auto">
+          <a:xfrm flipV="1">
+            <a:off x="4139952" y="4299768"/>
+            <a:ext cx="3208557" cy="169270"/>
+          </a:xfrm>
+          <a:prstGeom prst="line">
+            <a:avLst/>
+          </a:prstGeom>
+          <a:noFill/>
+          <a:ln w="28575">
+            <a:solidFill>
+              <a:srgbClr val="00B0F0"/>
+            </a:solidFill>
+            <a:round/>
+            <a:headEnd/>
+            <a:tailEnd type="triangle" w="med" len="med"/>
+          </a:ln>
+        </p:spPr>
+        <p:txBody>
+          <a:bodyPr/>
+          <a:lstStyle/>
+          <a:p>
+            <a:endParaRPr lang="en-US"/>
+          </a:p>
+        </p:txBody>
+      </p:sp>
+      <p:sp>
+        <p:nvSpPr>
+          <p:cNvPr id="9" name="Line 11">
+            <a:extLst>
+              <a:ext uri="{FF2B5EF4-FFF2-40B4-BE49-F238E27FC236}">
+                <a16:creationId xmlns:a16="http://schemas.microsoft.com/office/drawing/2014/main" id="{FC044429-E8FB-2EF8-3828-A5C624AC0CDD}"/>
+              </a:ext>
+            </a:extLst>
+          </p:cNvPr>
+          <p:cNvSpPr>
+            <a:spLocks noChangeShapeType="1"/>
+          </p:cNvSpPr>
+          <p:nvPr/>
+        </p:nvSpPr>
+        <p:spPr bwMode="auto">
+          <a:xfrm>
+            <a:off x="3923928" y="2329791"/>
+            <a:ext cx="3360957" cy="2179330"/>
+          </a:xfrm>
+          <a:prstGeom prst="line">
+            <a:avLst/>
+          </a:prstGeom>
+          <a:noFill/>
+          <a:ln w="28575">
+            <a:solidFill>
+              <a:srgbClr val="00B0F0"/>
+            </a:solidFill>
+            <a:round/>
+            <a:headEnd/>
+            <a:tailEnd type="triangle" w="med" len="med"/>
+          </a:ln>
+        </p:spPr>
+        <p:txBody>
+          <a:bodyPr/>
           <a:lstStyle/>
           <a:p>
             <a:endParaRPr lang="en-US"/>

</xml_diff>

<commit_message>
Updated presentations for 2.4.0 release
</commit_message>
<xml_diff>
--- a/doc/jCleanCimIntro.pptx
+++ b/doc/jCleanCimIntro.pptx
@@ -353,7 +353,7 @@
           <a:p>
             <a:r>
               <a:rPr lang="fi-FI"/>
-              <a:t>Copyright 2009-2019 T. Kostic; 2022-2026 UCAIug</a:t>
+              <a:t>Copyright 2009-2019 T. Kostic &amp; 2022-2026 UCAIug</a:t>
             </a:r>
             <a:endParaRPr lang="en-GB"/>
           </a:p>
@@ -615,7 +615,7 @@
           <a:p>
             <a:r>
               <a:rPr lang="fi-FI"/>
-              <a:t>Copyright 2009-2019 T. Kostic; 2022-2026 UCAIug</a:t>
+              <a:t>Copyright 2009-2019 T. Kostic &amp; 2022-2026 UCAIug</a:t>
             </a:r>
             <a:endParaRPr lang="en-GB"/>
           </a:p>
@@ -847,7 +847,7 @@
           <a:p>
             <a:r>
               <a:rPr lang="fi-FI"/>
-              <a:t>Copyright 2009-2019 T. Kostic; 2022-2026 UCAIug</a:t>
+              <a:t>Copyright 2009-2019 T. Kostic &amp; 2022-2026 UCAIug</a:t>
             </a:r>
             <a:endParaRPr lang="en-GB"/>
           </a:p>
@@ -1012,7 +1012,7 @@
           <a:p>
             <a:r>
               <a:rPr lang="fi-FI"/>
-              <a:t>Copyright 2009-2019 T. Kostic; 2022-2026 UCAIug</a:t>
+              <a:t>Copyright 2009-2019 T. Kostic &amp; 2022-2026 UCAIug</a:t>
             </a:r>
             <a:endParaRPr lang="en-GB"/>
           </a:p>
@@ -1141,7 +1141,7 @@
           <a:p>
             <a:r>
               <a:rPr lang="fi-FI"/>
-              <a:t>Copyright 2009-2019 T. Kostic; 2022-2026 UCAIug</a:t>
+              <a:t>Copyright 2009-2019 T. Kostic &amp; 2022-2026 UCAIug</a:t>
             </a:r>
             <a:endParaRPr lang="en-GB"/>
           </a:p>
@@ -1399,7 +1399,7 @@
           <a:p>
             <a:r>
               <a:rPr lang="fi-FI" dirty="0"/>
-              <a:t>Copyright 2009-2019 T. Kostic; 2022-2026 UCAIug</a:t>
+              <a:t>Copyright 2009-2019 T. Kostic &amp; 2022-2026 UCAIug</a:t>
             </a:r>
           </a:p>
         </p:txBody>
@@ -1586,7 +1586,7 @@
           <a:p>
             <a:r>
               <a:rPr lang="fi-FI" dirty="0"/>
-              <a:t>Copyright 2009-2019 T. Kostic; 2022-2026 UCAIug</a:t>
+              <a:t>Copyright 2009-2019 T. Kostic &amp; 2022-2026 UCAIug</a:t>
             </a:r>
           </a:p>
         </p:txBody>
@@ -2002,7 +2002,7 @@
           <a:p>
             <a:r>
               <a:rPr lang="fi-FI" dirty="0"/>
-              <a:t>Copyright 2009-2019 T. Kostic; 2022-2026 UCAIug</a:t>
+              <a:t>Copyright 2009-2019 T. Kostic &amp; 2022-2026 UCAIug</a:t>
             </a:r>
           </a:p>
         </p:txBody>
@@ -2259,7 +2259,7 @@
           <a:p>
             <a:r>
               <a:rPr lang="fi-FI" dirty="0"/>
-              <a:t>Copyright 2009-2019 T. Kostic; 2022-2026 UCAIug</a:t>
+              <a:t>Copyright 2009-2019 T. Kostic &amp; 2022-2026 UCAIug</a:t>
             </a:r>
           </a:p>
         </p:txBody>
@@ -2627,7 +2627,7 @@
           <a:p>
             <a:r>
               <a:rPr lang="fi-FI" dirty="0"/>
-              <a:t>Copyright 2009-2019 T. Kostic; 2022-2026 UCAIug</a:t>
+              <a:t>Copyright 2009-2019 T. Kostic &amp; 2022-2026 UCAIug</a:t>
             </a:r>
           </a:p>
         </p:txBody>
@@ -2744,7 +2744,7 @@
           <a:p>
             <a:r>
               <a:rPr lang="fi-FI" dirty="0"/>
-              <a:t>Copyright 2009-2019 T. Kostic; 2022-2026 UCAIug</a:t>
+              <a:t>Copyright 2009-2019 T. Kostic &amp; 2022-2026 UCAIug</a:t>
             </a:r>
           </a:p>
         </p:txBody>
@@ -2838,7 +2838,7 @@
           <a:p>
             <a:r>
               <a:rPr lang="fi-FI" dirty="0"/>
-              <a:t>Copyright 2009-2019 T. Kostic; 2022-2026 UCAIug</a:t>
+              <a:t>Copyright 2009-2019 T. Kostic &amp; 2022-2026 UCAIug</a:t>
             </a:r>
           </a:p>
         </p:txBody>
@@ -3023,8 +3023,8 @@
         </p:nvSpPr>
         <p:spPr>
           <a:xfrm rot="16200000">
-            <a:off x="-1241364" y="5145521"/>
-            <a:ext cx="2921373" cy="208410"/>
+            <a:off x="-1838078" y="4548808"/>
+            <a:ext cx="4114800" cy="208410"/>
           </a:xfrm>
           <a:prstGeom prst="rect">
             <a:avLst/>
@@ -3047,7 +3047,7 @@
           <a:p>
             <a:r>
               <a:rPr lang="fi-FI" dirty="0"/>
-              <a:t>Copyright 2009-2019 T. Kostic; 2022-2026 UCAIug</a:t>
+              <a:t>Copyright 2009-2019 T. Kostic &amp; 2022-2026 UCAIug</a:t>
             </a:r>
           </a:p>
         </p:txBody>
@@ -3552,7 +3552,7 @@
           <a:p>
             <a:r>
               <a:rPr lang="fi-FI" dirty="0"/>
-              <a:t>Copyright 2009-2019 T. Kostic; 2022-2026 UCAIug</a:t>
+              <a:t>Copyright 2009-2019 T. Kostic &amp; 2022-2026 UCAIug</a:t>
             </a:r>
           </a:p>
         </p:txBody>
@@ -3765,7 +3765,7 @@
           <a:p>
             <a:r>
               <a:rPr lang="fi-FI" dirty="0"/>
-              <a:t>Copyright 2009-2019 T. Kostic; 2022-2026 UCAIug</a:t>
+              <a:t>Copyright 2009-2019 T. Kostic &amp; 2022-2026 UCAIug</a:t>
             </a:r>
           </a:p>
         </p:txBody>
@@ -6576,7 +6576,7 @@
           <a:p>
             <a:r>
               <a:rPr lang="fi-FI" dirty="0"/>
-              <a:t>Copyright 2009-2019 T. Kostic; 2022-2026 UCAIug</a:t>
+              <a:t>Copyright 2009-2019 T. Kostic &amp; 2022-2026 UCAIug</a:t>
             </a:r>
           </a:p>
         </p:txBody>
@@ -7062,7 +7062,7 @@
           <a:p>
             <a:r>
               <a:rPr lang="fi-FI" dirty="0"/>
-              <a:t>Copyright 2009-2019 T. Kostic; 2022-2026 UCAIug</a:t>
+              <a:t>Copyright 2009-2019 T. Kostic &amp; 2022-2026 UCAIug</a:t>
             </a:r>
           </a:p>
         </p:txBody>
@@ -7408,7 +7408,7 @@
           <a:p>
             <a:r>
               <a:rPr lang="fi-FI" dirty="0"/>
-              <a:t>Copyright 2009-2019 T. Kostic; 2022-2026 UCAIug</a:t>
+              <a:t>Copyright 2009-2019 T. Kostic &amp; 2022-2026 UCAIug</a:t>
             </a:r>
           </a:p>
         </p:txBody>
@@ -7945,7 +7945,7 @@
           <a:p>
             <a:r>
               <a:rPr lang="fi-FI" dirty="0"/>
-              <a:t>Copyright 2009-2019 T. Kostic; 2022-2026 UCAIug</a:t>
+              <a:t>Copyright 2009-2019 T. Kostic &amp; 2022-2026 UCAIug</a:t>
             </a:r>
           </a:p>
         </p:txBody>
@@ -8749,7 +8749,7 @@
           <a:p>
             <a:r>
               <a:rPr lang="fi-FI" dirty="0"/>
-              <a:t>Copyright 2009-2019 T. Kostic; 2022-2026 UCAIug</a:t>
+              <a:t>Copyright 2009-2019 T. Kostic &amp; 2022-2026 UCAIug</a:t>
             </a:r>
           </a:p>
         </p:txBody>
@@ -9297,7 +9297,7 @@
           <a:p>
             <a:r>
               <a:rPr lang="fi-FI" dirty="0"/>
-              <a:t>Copyright 2009-2019 T. Kostic; 2022-2026 UCAIug</a:t>
+              <a:t>Copyright 2009-2019 T. Kostic &amp; 2022-2026 UCAIug</a:t>
             </a:r>
           </a:p>
         </p:txBody>
@@ -10206,7 +10206,7 @@
           <a:p>
             <a:r>
               <a:rPr lang="fi-FI" dirty="0"/>
-              <a:t>Copyright 2009-2019 T. Kostic; 2022-2026 UCAIug</a:t>
+              <a:t>Copyright 2009-2019 T. Kostic &amp; 2022-2026 UCAIug</a:t>
             </a:r>
           </a:p>
         </p:txBody>
@@ -10891,7 +10891,7 @@
           <a:p>
             <a:r>
               <a:rPr lang="fi-FI" dirty="0"/>
-              <a:t>Copyright 2009-2019 T. Kostic; 2022-2026 UCAIug</a:t>
+              <a:t>Copyright 2009-2019 T. Kostic &amp; 2022-2026 UCAIug</a:t>
             </a:r>
           </a:p>
         </p:txBody>
@@ -11467,7 +11467,7 @@
           <a:p>
             <a:r>
               <a:rPr lang="fi-FI" dirty="0"/>
-              <a:t>Copyright 2009-2019 T. Kostic; 2022-2026 UCAIug</a:t>
+              <a:t>Copyright 2009-2019 T. Kostic &amp; 2022-2026 UCAIug</a:t>
             </a:r>
           </a:p>
         </p:txBody>
@@ -11784,7 +11784,7 @@
           <a:p>
             <a:r>
               <a:rPr lang="fi-FI" dirty="0"/>
-              <a:t>Copyright 2009-2019 T. Kostic; 2022-2026 UCAIug</a:t>
+              <a:t>Copyright 2009-2019 T. Kostic &amp; 2022-2026 UCAIug</a:t>
             </a:r>
           </a:p>
         </p:txBody>
@@ -11936,7 +11936,7 @@
           <a:p>
             <a:r>
               <a:rPr lang="fi-FI" dirty="0"/>
-              <a:t>Copyright 2009-2019 T. Kostic; 2022-2026 UCAIug</a:t>
+              <a:t>Copyright 2009-2019 T. Kostic &amp; 2022-2026 UCAIug</a:t>
             </a:r>
           </a:p>
         </p:txBody>
@@ -12852,7 +12852,7 @@
           <a:p>
             <a:r>
               <a:rPr lang="fi-FI" dirty="0"/>
-              <a:t>Copyright 2009-2019 T. Kostic; 2022-2026 UCAIug</a:t>
+              <a:t>Copyright 2009-2019 T. Kostic &amp; 2022-2026 UCAIug</a:t>
             </a:r>
           </a:p>
         </p:txBody>
@@ -14482,7 +14482,7 @@
           <a:p>
             <a:r>
               <a:rPr lang="fi-FI" dirty="0"/>
-              <a:t>Copyright 2009-2019 T. Kostic; 2022-2026 UCAIug</a:t>
+              <a:t>Copyright 2009-2019 T. Kostic &amp; 2022-2026 UCAIug</a:t>
             </a:r>
           </a:p>
         </p:txBody>
@@ -16112,7 +16112,7 @@
           <a:p>
             <a:r>
               <a:rPr lang="fi-FI" dirty="0"/>
-              <a:t>Copyright 2009-2019 T. Kostic; 2022-2026 UCAIug</a:t>
+              <a:t>Copyright 2009-2019 T. Kostic &amp; 2022-2026 UCAIug</a:t>
             </a:r>
           </a:p>
         </p:txBody>
@@ -16268,7 +16268,7 @@
           <a:p>
             <a:r>
               <a:rPr lang="fi-FI" dirty="0"/>
-              <a:t>Copyright 2009-2019 T. Kostic; 2022-2026 UCAIug</a:t>
+              <a:t>Copyright 2009-2019 T. Kostic &amp; 2022-2026 UCAIug</a:t>
             </a:r>
           </a:p>
         </p:txBody>
@@ -16727,7 +16727,7 @@
           <a:p>
             <a:r>
               <a:rPr lang="fi-FI" dirty="0"/>
-              <a:t>Copyright 2009-2019 T. Kostic; 2022-2026 UCAIug</a:t>
+              <a:t>Copyright 2009-2019 T. Kostic &amp; 2022-2026 UCAIug</a:t>
             </a:r>
           </a:p>
         </p:txBody>
@@ -17104,7 +17104,7 @@
           <a:p>
             <a:r>
               <a:rPr lang="fi-FI" dirty="0"/>
-              <a:t>Copyright 2009-2019 T. Kostic; 2022-2026 UCAIug</a:t>
+              <a:t>Copyright 2009-2019 T. Kostic &amp; 2022-2026 UCAIug</a:t>
             </a:r>
           </a:p>
         </p:txBody>
@@ -17979,7 +17979,7 @@
           <a:p>
             <a:r>
               <a:rPr lang="fi-FI" dirty="0"/>
-              <a:t>Copyright 2009-2019 T. Kostic; 2022-2026 UCAIug</a:t>
+              <a:t>Copyright 2009-2019 T. Kostic &amp; 2022-2026 UCAIug</a:t>
             </a:r>
           </a:p>
         </p:txBody>
@@ -18129,7 +18129,7 @@
           <a:p>
             <a:r>
               <a:rPr lang="fi-FI" dirty="0"/>
-              <a:t>Copyright 2009-2019 T. Kostic; 2022-2026 UCAIug</a:t>
+              <a:t>Copyright 2009-2019 T. Kostic &amp; 2022-2026 UCAIug</a:t>
             </a:r>
           </a:p>
         </p:txBody>
@@ -18443,7 +18443,7 @@
           <a:p>
             <a:r>
               <a:rPr lang="fi-FI" dirty="0"/>
-              <a:t>Copyright 2009-2019 T. Kostic; 2022-2026 UCAIug</a:t>
+              <a:t>Copyright 2009-2019 T. Kostic &amp; 2022-2026 UCAIug</a:t>
             </a:r>
           </a:p>
         </p:txBody>
@@ -18659,7 +18659,7 @@
           <a:p>
             <a:r>
               <a:rPr lang="fi-FI" dirty="0"/>
-              <a:t>Copyright 2009-2019 T. Kostic; 2022-2026 UCAIug</a:t>
+              <a:t>Copyright 2009-2019 T. Kostic &amp; 2022-2026 UCAIug</a:t>
             </a:r>
           </a:p>
         </p:txBody>
@@ -18913,7 +18913,7 @@
           <a:p>
             <a:r>
               <a:rPr lang="fi-FI" dirty="0"/>
-              <a:t>Copyright 2009-2019 T. Kostic; 2022-2026 UCAIug</a:t>
+              <a:t>Copyright 2009-2019 T. Kostic &amp; 2022-2026 UCAIug</a:t>
             </a:r>
           </a:p>
         </p:txBody>
@@ -19127,7 +19127,7 @@
           <a:p>
             <a:r>
               <a:rPr lang="fi-FI" dirty="0"/>
-              <a:t>Copyright 2009-2019 T. Kostic; 2022-2026 UCAIug</a:t>
+              <a:t>Copyright 2009-2019 T. Kostic &amp; 2022-2026 UCAIug</a:t>
             </a:r>
           </a:p>
         </p:txBody>
@@ -21590,7 +21590,7 @@
           <a:p>
             <a:r>
               <a:rPr lang="fi-FI" dirty="0"/>
-              <a:t>Copyright 2009-2019 T. Kostic; 2022-2026 UCAIug</a:t>
+              <a:t>Copyright 2009-2019 T. Kostic &amp; 2022-2026 UCAIug</a:t>
             </a:r>
           </a:p>
         </p:txBody>
@@ -24868,7 +24868,7 @@
           <a:p>
             <a:r>
               <a:rPr lang="fi-FI" dirty="0"/>
-              <a:t>Copyright 2009-2019 T. Kostic; 2022-2026 UCAIug</a:t>
+              <a:t>Copyright 2009-2019 T. Kostic &amp; 2022-2026 UCAIug</a:t>
             </a:r>
           </a:p>
         </p:txBody>
@@ -25471,7 +25471,7 @@
           <a:p>
             <a:r>
               <a:rPr lang="fi-FI" dirty="0"/>
-              <a:t>Copyright 2009-2019 T. Kostic; 2022-2026 UCAIug</a:t>
+              <a:t>Copyright 2009-2019 T. Kostic &amp; 2022-2026 UCAIug</a:t>
             </a:r>
           </a:p>
         </p:txBody>
@@ -26196,7 +26196,7 @@
           <a:p>
             <a:r>
               <a:rPr lang="fi-FI" dirty="0"/>
-              <a:t>Copyright 2009-2019 T. Kostic; 2022-2026 UCAIug</a:t>
+              <a:t>Copyright 2009-2019 T. Kostic &amp; 2022-2026 UCAIug</a:t>
             </a:r>
           </a:p>
         </p:txBody>
@@ -26341,7 +26341,7 @@
           <a:p>
             <a:r>
               <a:rPr lang="fi-FI" dirty="0"/>
-              <a:t>Copyright 2009-2019 T. Kostic; 2022-2026 UCAIug</a:t>
+              <a:t>Copyright 2009-2019 T. Kostic &amp; 2022-2026 UCAIug</a:t>
             </a:r>
           </a:p>
         </p:txBody>
@@ -26618,7 +26618,7 @@
           <a:p>
             <a:r>
               <a:rPr lang="fi-FI" dirty="0"/>
-              <a:t>Copyright 2009-2019 T. Kostic; 2022-2026 UCAIug</a:t>
+              <a:t>Copyright 2009-2019 T. Kostic &amp; 2022-2026 UCAIug</a:t>
             </a:r>
           </a:p>
         </p:txBody>
@@ -26833,7 +26833,7 @@
           <a:p>
             <a:r>
               <a:rPr lang="fi-FI" dirty="0"/>
-              <a:t>Copyright 2009-2019 T. Kostic; 2022-2026 UCAIug</a:t>
+              <a:t>Copyright 2009-2019 T. Kostic &amp; 2022-2026 UCAIug</a:t>
             </a:r>
           </a:p>
         </p:txBody>
@@ -27124,7 +27124,7 @@
           <a:p>
             <a:r>
               <a:rPr lang="fi-FI" dirty="0"/>
-              <a:t>Copyright 2009-2019 T. Kostic; 2022-2026 UCAIug</a:t>
+              <a:t>Copyright 2009-2019 T. Kostic &amp; 2022-2026 UCAIug</a:t>
             </a:r>
           </a:p>
         </p:txBody>
@@ -27458,7 +27458,7 @@
           <a:p>
             <a:r>
               <a:rPr lang="fi-FI" dirty="0"/>
-              <a:t>Copyright 2009-2019 T. Kostic; 2022-2026 UCAIug</a:t>
+              <a:t>Copyright 2009-2019 T. Kostic &amp; 2022-2026 UCAIug</a:t>
             </a:r>
           </a:p>
         </p:txBody>
@@ -27813,7 +27813,7 @@
           <a:p>
             <a:r>
               <a:rPr lang="fi-FI" dirty="0"/>
-              <a:t>Copyright 2009-2019 T. Kostic; 2022-2026 UCAIug</a:t>
+              <a:t>Copyright 2009-2019 T. Kostic &amp; 2022-2026 UCAIug</a:t>
             </a:r>
           </a:p>
         </p:txBody>
@@ -28198,7 +28198,7 @@
           <a:p>
             <a:r>
               <a:rPr lang="fi-FI" dirty="0"/>
-              <a:t>Copyright 2009-2019 T. Kostic; 2022-2026 UCAIug</a:t>
+              <a:t>Copyright 2009-2019 T. Kostic &amp; 2022-2026 UCAIug</a:t>
             </a:r>
           </a:p>
         </p:txBody>
@@ -28959,7 +28959,7 @@
           <a:p>
             <a:r>
               <a:rPr lang="fi-FI" dirty="0"/>
-              <a:t>Copyright 2009-2019 T. Kostic; 2022-2026 UCAIug</a:t>
+              <a:t>Copyright 2009-2019 T. Kostic &amp; 2022-2026 UCAIug</a:t>
             </a:r>
           </a:p>
         </p:txBody>
@@ -29144,7 +29144,7 @@
           <a:p>
             <a:r>
               <a:rPr lang="fi-FI" dirty="0"/>
-              <a:t>Copyright 2009-2019 T. Kostic; 2022-2026 UCAIug</a:t>
+              <a:t>Copyright 2009-2019 T. Kostic &amp; 2022-2026 UCAIug</a:t>
             </a:r>
           </a:p>
         </p:txBody>
@@ -29435,7 +29435,7 @@
           <a:p>
             <a:r>
               <a:rPr lang="fi-FI" dirty="0"/>
-              <a:t>Copyright 2009-2019 T. Kostic; 2022-2026 UCAIug</a:t>
+              <a:t>Copyright 2009-2019 T. Kostic &amp; 2022-2026 UCAIug</a:t>
             </a:r>
           </a:p>
         </p:txBody>
@@ -30385,7 +30385,7 @@
           <a:p>
             <a:r>
               <a:rPr lang="fi-FI" dirty="0"/>
-              <a:t>Copyright 2009-2019 T. Kostic; 2022-2026 UCAIug</a:t>
+              <a:t>Copyright 2009-2019 T. Kostic &amp; 2022-2026 UCAIug</a:t>
             </a:r>
           </a:p>
         </p:txBody>
@@ -31713,7 +31713,7 @@
           <a:p>
             <a:r>
               <a:rPr lang="fi-FI" dirty="0"/>
-              <a:t>Copyright 2009-2019 T. Kostic; 2022-2026 UCAIug</a:t>
+              <a:t>Copyright 2009-2019 T. Kostic &amp; 2022-2026 UCAIug</a:t>
             </a:r>
           </a:p>
         </p:txBody>
@@ -32269,7 +32269,7 @@
           <a:p>
             <a:r>
               <a:rPr lang="fi-FI" dirty="0"/>
-              <a:t>Copyright 2009-2019 T. Kostic; 2022-2026 UCAIug</a:t>
+              <a:t>Copyright 2009-2019 T. Kostic &amp; 2022-2026 UCAIug</a:t>
             </a:r>
           </a:p>
         </p:txBody>
@@ -32905,7 +32905,7 @@
           <a:p>
             <a:r>
               <a:rPr lang="fi-FI" dirty="0"/>
-              <a:t>Copyright 2009-2019 T. Kostic; 2022-2026 UCAIug</a:t>
+              <a:t>Copyright 2009-2019 T. Kostic &amp; 2022-2026 UCAIug</a:t>
             </a:r>
           </a:p>
         </p:txBody>
@@ -33028,7 +33028,7 @@
           <a:p>
             <a:r>
               <a:rPr lang="fi-FI" dirty="0"/>
-              <a:t>Copyright 2009-2019 T. Kostic; 2022-2026 UCAIug</a:t>
+              <a:t>Copyright 2009-2019 T. Kostic &amp; 2022-2026 UCAIug</a:t>
             </a:r>
           </a:p>
         </p:txBody>
@@ -33869,7 +33869,7 @@
           <a:p>
             <a:r>
               <a:rPr lang="fi-FI" dirty="0"/>
-              <a:t>Copyright 2009-2019 T. Kostic; 2022-2026 UCAIug</a:t>
+              <a:t>Copyright 2009-2019 T. Kostic &amp; 2022-2026 UCAIug</a:t>
             </a:r>
           </a:p>
         </p:txBody>
@@ -34152,7 +34152,7 @@
           <a:p>
             <a:r>
               <a:rPr lang="fi-FI" dirty="0"/>
-              <a:t>Copyright 2009-2019 T. Kostic; 2022-2026 UCAIug</a:t>
+              <a:t>Copyright 2009-2019 T. Kostic &amp; 2022-2026 UCAIug</a:t>
             </a:r>
           </a:p>
         </p:txBody>
@@ -35236,7 +35236,7 @@
           <a:p>
             <a:r>
               <a:rPr lang="fi-FI" dirty="0"/>
-              <a:t>Copyright 2009-2019 T. Kostic; 2022-2026 UCAIug</a:t>
+              <a:t>Copyright 2009-2019 T. Kostic &amp; 2022-2026 UCAIug</a:t>
             </a:r>
           </a:p>
         </p:txBody>
@@ -35847,7 +35847,7 @@
           <a:p>
             <a:r>
               <a:rPr lang="fi-FI" dirty="0"/>
-              <a:t>Copyright 2009-2019 T. Kostic; 2022-2026 UCAIug</a:t>
+              <a:t>Copyright 2009-2019 T. Kostic &amp; 2022-2026 UCAIug</a:t>
             </a:r>
           </a:p>
         </p:txBody>
@@ -36220,7 +36220,7 @@
           <a:p>
             <a:r>
               <a:rPr lang="fi-FI" dirty="0"/>
-              <a:t>Copyright 2009-2019 T. Kostic; 2022-2026 UCAIug</a:t>
+              <a:t>Copyright 2009-2019 T. Kostic &amp; 2022-2026 UCAIug</a:t>
             </a:r>
           </a:p>
         </p:txBody>
@@ -36593,7 +36593,7 @@
           <a:p>
             <a:r>
               <a:rPr lang="fi-FI" dirty="0"/>
-              <a:t>Copyright 2009-2019 T. Kostic; 2022-2026 UCAIug</a:t>
+              <a:t>Copyright 2009-2019 T. Kostic &amp; 2022-2026 UCAIug</a:t>
             </a:r>
           </a:p>
         </p:txBody>
@@ -36866,7 +36866,7 @@
           <a:p>
             <a:r>
               <a:rPr lang="fi-FI" dirty="0"/>
-              <a:t>Copyright 2009-2019 T. Kostic; 2022-2026 UCAIug</a:t>
+              <a:t>Copyright 2009-2019 T. Kostic &amp; 2022-2026 UCAIug</a:t>
             </a:r>
           </a:p>
         </p:txBody>
@@ -37125,7 +37125,7 @@
           <a:p>
             <a:r>
               <a:rPr lang="fi-FI" dirty="0"/>
-              <a:t>Copyright 2009-2019 T. Kostic; 2022-2026 UCAIug</a:t>
+              <a:t>Copyright 2009-2019 T. Kostic &amp; 2022-2026 UCAIug</a:t>
             </a:r>
           </a:p>
         </p:txBody>
@@ -37660,7 +37660,7 @@
           <a:p>
             <a:r>
               <a:rPr lang="fi-FI" dirty="0"/>
-              <a:t>Copyright 2009-2019 T. Kostic; 2022-2026 UCAIug</a:t>
+              <a:t>Copyright 2009-2019 T. Kostic &amp; 2022-2026 UCAIug</a:t>
             </a:r>
           </a:p>
         </p:txBody>
@@ -37944,7 +37944,7 @@
           <a:p>
             <a:r>
               <a:rPr lang="fi-FI" dirty="0"/>
-              <a:t>Copyright 2009-2019 T. Kostic; 2022-2026 UCAIug</a:t>
+              <a:t>Copyright 2009-2019 T. Kostic &amp; 2022-2026 UCAIug</a:t>
             </a:r>
           </a:p>
         </p:txBody>
@@ -38275,7 +38275,7 @@
           <a:p>
             <a:r>
               <a:rPr lang="fi-FI" dirty="0"/>
-              <a:t>Copyright 2009-2019 T. Kostic; 2022-2026 UCAIug</a:t>
+              <a:t>Copyright 2009-2019 T. Kostic &amp; 2022-2026 UCAIug</a:t>
             </a:r>
           </a:p>
         </p:txBody>
@@ -38684,7 +38684,7 @@
           <a:p>
             <a:r>
               <a:rPr lang="fi-FI" dirty="0"/>
-              <a:t>Copyright 2009-2019 T. Kostic; 2022-2026 UCAIug</a:t>
+              <a:t>Copyright 2009-2019 T. Kostic &amp; 2022-2026 UCAIug</a:t>
             </a:r>
           </a:p>
         </p:txBody>
@@ -39761,7 +39761,7 @@
           <a:p>
             <a:r>
               <a:rPr lang="fi-FI" dirty="0"/>
-              <a:t>Copyright 2009-2019 T. Kostic; 2022-2026 UCAIug</a:t>
+              <a:t>Copyright 2009-2019 T. Kostic &amp; 2022-2026 UCAIug</a:t>
             </a:r>
           </a:p>
         </p:txBody>
@@ -39913,7 +39913,7 @@
           <a:p>
             <a:r>
               <a:rPr lang="fi-FI" dirty="0"/>
-              <a:t>Copyright 2009-2019 T. Kostic; 2022-2026 UCAIug</a:t>
+              <a:t>Copyright 2009-2019 T. Kostic &amp; 2022-2026 UCAIug</a:t>
             </a:r>
           </a:p>
         </p:txBody>
@@ -40523,7 +40523,7 @@
           <a:p>
             <a:r>
               <a:rPr lang="fi-FI" dirty="0"/>
-              <a:t>Copyright 2009-2019 T. Kostic; 2022-2026 UCAIug</a:t>
+              <a:t>Copyright 2009-2019 T. Kostic &amp; 2022-2026 UCAIug</a:t>
             </a:r>
           </a:p>
         </p:txBody>
@@ -40818,7 +40818,7 @@
           <a:p>
             <a:r>
               <a:rPr lang="fi-FI" dirty="0"/>
-              <a:t>Copyright 2009-2019 T. Kostic; 2022-2026 UCAIug</a:t>
+              <a:t>Copyright 2009-2019 T. Kostic &amp; 2022-2026 UCAIug</a:t>
             </a:r>
           </a:p>
         </p:txBody>
@@ -41221,7 +41221,7 @@
           <a:p>
             <a:r>
               <a:rPr lang="fi-FI" dirty="0"/>
-              <a:t>Copyright 2009-2019 T. Kostic; 2022-2026 UCAIug</a:t>
+              <a:t>Copyright 2009-2019 T. Kostic &amp; 2022-2026 UCAIug</a:t>
             </a:r>
           </a:p>
         </p:txBody>
@@ -41646,7 +41646,7 @@
           <a:p>
             <a:r>
               <a:rPr lang="fi-FI" dirty="0"/>
-              <a:t>Copyright 2009-2019 T. Kostic; 2022-2026 UCAIug</a:t>
+              <a:t>Copyright 2009-2019 T. Kostic &amp; 2022-2026 UCAIug</a:t>
             </a:r>
           </a:p>
         </p:txBody>
@@ -41883,7 +41883,7 @@
           <a:p>
             <a:r>
               <a:rPr lang="fi-FI" dirty="0"/>
-              <a:t>Copyright 2009-2019 T. Kostic; 2022-2026 UCAIug</a:t>
+              <a:t>Copyright 2009-2019 T. Kostic &amp; 2022-2026 UCAIug</a:t>
             </a:r>
           </a:p>
         </p:txBody>
@@ -42058,7 +42058,7 @@
           <a:p>
             <a:r>
               <a:rPr lang="fi-FI" dirty="0"/>
-              <a:t>Copyright 2009-2019 T. Kostic; 2022-2026 UCAIug</a:t>
+              <a:t>Copyright 2009-2019 T. Kostic &amp; 2022-2026 UCAIug</a:t>
             </a:r>
           </a:p>
         </p:txBody>
@@ -42267,7 +42267,7 @@
           <a:p>
             <a:r>
               <a:rPr lang="fi-FI" dirty="0"/>
-              <a:t>Copyright 2009-2019 T. Kostic; 2022-2026 UCAIug</a:t>
+              <a:t>Copyright 2009-2019 T. Kostic &amp; 2022-2026 UCAIug</a:t>
             </a:r>
           </a:p>
         </p:txBody>
@@ -42737,7 +42737,7 @@
           <a:p>
             <a:r>
               <a:rPr lang="fi-FI" dirty="0"/>
-              <a:t>Copyright 2009-2019 T. Kostic; 2022-2026 UCAIug</a:t>
+              <a:t>Copyright 2009-2019 T. Kostic &amp; 2022-2026 UCAIug</a:t>
             </a:r>
           </a:p>
         </p:txBody>
@@ -43236,7 +43236,7 @@
           <a:p>
             <a:r>
               <a:rPr lang="fi-FI" dirty="0"/>
-              <a:t>Copyright 2009-2019 T. Kostic; 2022-2026 UCAIug</a:t>
+              <a:t>Copyright 2009-2019 T. Kostic &amp; 2022-2026 UCAIug</a:t>
             </a:r>
           </a:p>
         </p:txBody>
@@ -44259,7 +44259,7 @@
           <a:p>
             <a:r>
               <a:rPr lang="fi-FI" dirty="0"/>
-              <a:t>Copyright 2009-2019 T. Kostic; 2022-2026 UCAIug</a:t>
+              <a:t>Copyright 2009-2019 T. Kostic &amp; 2022-2026 UCAIug</a:t>
             </a:r>
           </a:p>
         </p:txBody>
@@ -45714,7 +45714,7 @@
           <a:p>
             <a:r>
               <a:rPr lang="fi-FI" dirty="0"/>
-              <a:t>Copyright 2009-2019 T. Kostic; 2022-2026 UCAIug</a:t>
+              <a:t>Copyright 2009-2019 T. Kostic &amp; 2022-2026 UCAIug</a:t>
             </a:r>
           </a:p>
         </p:txBody>
@@ -45861,7 +45861,7 @@
           <a:p>
             <a:r>
               <a:rPr lang="fi-FI" dirty="0"/>
-              <a:t>Copyright 2009-2019 T. Kostic; 2022-2026 UCAIug</a:t>
+              <a:t>Copyright 2009-2019 T. Kostic &amp; 2022-2026 UCAIug</a:t>
             </a:r>
           </a:p>
         </p:txBody>
@@ -46108,7 +46108,7 @@
           <a:p>
             <a:r>
               <a:rPr lang="fi-FI" dirty="0"/>
-              <a:t>Copyright 2009-2019 T. Kostic; 2022-2026 UCAIug</a:t>
+              <a:t>Copyright 2009-2019 T. Kostic &amp; 2022-2026 UCAIug</a:t>
             </a:r>
           </a:p>
         </p:txBody>
@@ -46404,7 +46404,7 @@
           <a:p>
             <a:r>
               <a:rPr lang="fi-FI" dirty="0"/>
-              <a:t>Copyright 2009-2019 T. Kostic; 2022-2026 UCAIug</a:t>
+              <a:t>Copyright 2009-2019 T. Kostic &amp; 2022-2026 UCAIug</a:t>
             </a:r>
           </a:p>
         </p:txBody>
@@ -46665,7 +46665,7 @@
           <a:p>
             <a:r>
               <a:rPr lang="fi-FI" dirty="0"/>
-              <a:t>Copyright 2009-2019 T. Kostic; 2022-2026 UCAIug</a:t>
+              <a:t>Copyright 2009-2019 T. Kostic &amp; 2022-2026 UCAIug</a:t>
             </a:r>
           </a:p>
         </p:txBody>
@@ -47062,7 +47062,7 @@
           <a:p>
             <a:r>
               <a:rPr lang="fi-FI" dirty="0"/>
-              <a:t>Copyright 2009-2019 T. Kostic; 2022-2026 UCAIug</a:t>
+              <a:t>Copyright 2009-2019 T. Kostic &amp; 2022-2026 UCAIug</a:t>
             </a:r>
           </a:p>
         </p:txBody>
@@ -47334,7 +47334,7 @@
           <a:p>
             <a:r>
               <a:rPr lang="fi-FI" dirty="0"/>
-              <a:t>Copyright 2009-2019 T. Kostic; 2022-2026 UCAIug</a:t>
+              <a:t>Copyright 2009-2019 T. Kostic &amp; 2022-2026 UCAIug</a:t>
             </a:r>
           </a:p>
         </p:txBody>
@@ -47544,7 +47544,7 @@
           <a:p>
             <a:r>
               <a:rPr lang="fi-FI" dirty="0"/>
-              <a:t>Copyright 2009-2019 T. Kostic; 2022-2026 UCAIug</a:t>
+              <a:t>Copyright 2009-2019 T. Kostic &amp; 2022-2026 UCAIug</a:t>
             </a:r>
           </a:p>
         </p:txBody>

</xml_diff>